<commit_message>
docs(design): layout gap analysis vs girosbet.io v1; pitch reframed to layout parity
Co-Authored-By: Claude Fable 5.1 <noreply@anthropic.com>
Claude-Session: https://claude.ai/code/session_01M8w3jJmPeahYpwBpQFqMKa
</commit_message>
<xml_diff>
--- a/docs/girosbet/girosbet-v2-pitch.pptx
+++ b/docs/girosbet/girosbet-v2-pitch.pptx
@@ -15,6 +15,7 @@
     <p:sldId id="263" r:id="rId14"/>
     <p:sldId id="264" r:id="rId15"/>
     <p:sldId id="265" r:id="rId16"/>
+    <p:sldId id="266" r:id="rId17"/>
   </p:sldIdLst>
   <p:sldSz cx="12191695" cy="6858000" type="screen4x3"/>
   <p:notesSz cx="6858000" cy="9144000"/>
@@ -3442,6 +3443,500 @@
                 </a:solidFill>
                 <a:latin typeface="Inter"/>
               </a:rPr>
+              <a:t>RISCOS</a:t>
+            </a:r>
+          </a:p>
+        </p:txBody>
+      </p:sp>
+      <p:sp>
+        <p:nvSpPr>
+          <p:cNvPr id="5" name="TextBox 4"/>
+          <p:cNvSpPr txBox="1"/>
+          <p:nvPr/>
+        </p:nvSpPr>
+        <p:spPr>
+          <a:xfrm>
+            <a:off x="731520" y="868680"/>
+            <a:ext cx="10058400" cy="914400"/>
+          </a:xfrm>
+          <a:prstGeom prst="rect">
+            <a:avLst/>
+          </a:prstGeom>
+          <a:noFill/>
+        </p:spPr>
+        <p:txBody>
+          <a:bodyPr wrap="square">
+            <a:spAutoFit/>
+          </a:bodyPr>
+          <a:lstStyle/>
+          <a:p>
+            <a:pPr algn="l">
+              <a:lnSpc>
+                <a:spcPct val="100000"/>
+              </a:lnSpc>
+            </a:pPr>
+            <a:r>
+              <a:rPr sz="4400" b="0">
+                <a:solidFill>
+                  <a:srgbClr val="ECE7F7"/>
+                </a:solidFill>
+                <a:latin typeface="Bebas Neue"/>
+              </a:rPr>
+              <a:t>O que pode dar errado, e o que fazemos</a:t>
+            </a:r>
+          </a:p>
+        </p:txBody>
+      </p:sp>
+      <p:sp>
+        <p:nvSpPr>
+          <p:cNvPr id="6" name="TextBox 5"/>
+          <p:cNvSpPr txBox="1"/>
+          <p:nvPr/>
+        </p:nvSpPr>
+        <p:spPr>
+          <a:xfrm>
+            <a:off x="731520" y="2011680"/>
+            <a:ext cx="3108960" cy="822960"/>
+          </a:xfrm>
+          <a:prstGeom prst="rect">
+            <a:avLst/>
+          </a:prstGeom>
+          <a:noFill/>
+        </p:spPr>
+        <p:txBody>
+          <a:bodyPr wrap="square">
+            <a:spAutoFit/>
+          </a:bodyPr>
+          <a:lstStyle/>
+          <a:p>
+            <a:pPr algn="l">
+              <a:lnSpc>
+                <a:spcPct val="115000"/>
+              </a:lnSpc>
+            </a:pPr>
+            <a:r>
+              <a:rPr sz="1500" b="1">
+                <a:solidFill>
+                  <a:srgbClr val="E145FF"/>
+                </a:solidFill>
+                <a:latin typeface="Inter"/>
+              </a:rPr>
+              <a:t>Backend desconhecido</a:t>
+            </a:r>
+          </a:p>
+        </p:txBody>
+      </p:sp>
+      <p:sp>
+        <p:nvSpPr>
+          <p:cNvPr id="7" name="TextBox 6"/>
+          <p:cNvSpPr txBox="1"/>
+          <p:nvPr/>
+        </p:nvSpPr>
+        <p:spPr>
+          <a:xfrm>
+            <a:off x="4023360" y="2011680"/>
+            <a:ext cx="7498079" cy="822960"/>
+          </a:xfrm>
+          <a:prstGeom prst="rect">
+            <a:avLst/>
+          </a:prstGeom>
+          <a:noFill/>
+        </p:spPr>
+        <p:txBody>
+          <a:bodyPr wrap="square">
+            <a:spAutoFit/>
+          </a:bodyPr>
+          <a:lstStyle/>
+          <a:p>
+            <a:pPr algn="l">
+              <a:lnSpc>
+                <a:spcPct val="130000"/>
+              </a:lnSpc>
+            </a:pPr>
+            <a:r>
+              <a:rPr sz="1400" b="0">
+                <a:solidFill>
+                  <a:srgbClr val="ECE7F7"/>
+                </a:solidFill>
+                <a:latin typeface="Inter"/>
+              </a:rPr>
+              <a:t>A área logada é o maior custo. Spike de 1 semana lendo a documentação antes de fechar a fase 4.</a:t>
+            </a:r>
+          </a:p>
+        </p:txBody>
+      </p:sp>
+      <p:sp>
+        <p:nvSpPr>
+          <p:cNvPr id="8" name="TextBox 7"/>
+          <p:cNvSpPr txBox="1"/>
+          <p:nvPr/>
+        </p:nvSpPr>
+        <p:spPr>
+          <a:xfrm>
+            <a:off x="731520" y="2926080"/>
+            <a:ext cx="3108960" cy="822960"/>
+          </a:xfrm>
+          <a:prstGeom prst="rect">
+            <a:avLst/>
+          </a:prstGeom>
+          <a:noFill/>
+        </p:spPr>
+        <p:txBody>
+          <a:bodyPr wrap="square">
+            <a:spAutoFit/>
+          </a:bodyPr>
+          <a:lstStyle/>
+          <a:p>
+            <a:pPr algn="l">
+              <a:lnSpc>
+                <a:spcPct val="115000"/>
+              </a:lnSpc>
+            </a:pPr>
+            <a:r>
+              <a:rPr sz="1500" b="1">
+                <a:solidFill>
+                  <a:srgbClr val="E145FF"/>
+                </a:solidFill>
+                <a:latin typeface="Inter"/>
+              </a:rPr>
+              <a:t>Paridade de conteúdo</a:t>
+            </a:r>
+          </a:p>
+        </p:txBody>
+      </p:sp>
+      <p:sp>
+        <p:nvSpPr>
+          <p:cNvPr id="9" name="TextBox 8"/>
+          <p:cNvSpPr txBox="1"/>
+          <p:nvPr/>
+        </p:nvSpPr>
+        <p:spPr>
+          <a:xfrm>
+            <a:off x="4023360" y="2926080"/>
+            <a:ext cx="7498079" cy="822960"/>
+          </a:xfrm>
+          <a:prstGeom prst="rect">
+            <a:avLst/>
+          </a:prstGeom>
+          <a:noFill/>
+        </p:spPr>
+        <p:txBody>
+          <a:bodyPr wrap="square">
+            <a:spAutoFit/>
+          </a:bodyPr>
+          <a:lstStyle/>
+          <a:p>
+            <a:pPr algn="l">
+              <a:lnSpc>
+                <a:spcPct val="130000"/>
+              </a:lnSpc>
+            </a:pPr>
+            <a:r>
+              <a:rPr sz="1400" b="0">
+                <a:solidFill>
+                  <a:srgbClr val="ECE7F7"/>
+                </a:solidFill>
+                <a:latin typeface="Inter"/>
+              </a:rPr>
+              <a:t>Catálogo importado por job, não cadastrado à mão. O CMS já sincroniza com o agregador.</a:t>
+            </a:r>
+          </a:p>
+        </p:txBody>
+      </p:sp>
+      <p:sp>
+        <p:nvSpPr>
+          <p:cNvPr id="10" name="TextBox 9"/>
+          <p:cNvSpPr txBox="1"/>
+          <p:nvPr/>
+        </p:nvSpPr>
+        <p:spPr>
+          <a:xfrm>
+            <a:off x="731520" y="3840480"/>
+            <a:ext cx="3108960" cy="822960"/>
+          </a:xfrm>
+          <a:prstGeom prst="rect">
+            <a:avLst/>
+          </a:prstGeom>
+          <a:noFill/>
+        </p:spPr>
+        <p:txBody>
+          <a:bodyPr wrap="square">
+            <a:spAutoFit/>
+          </a:bodyPr>
+          <a:lstStyle/>
+          <a:p>
+            <a:pPr algn="l">
+              <a:lnSpc>
+                <a:spcPct val="115000"/>
+              </a:lnSpc>
+            </a:pPr>
+            <a:r>
+              <a:rPr sz="1500" b="1">
+                <a:solidFill>
+                  <a:srgbClr val="E145FF"/>
+                </a:solidFill>
+                <a:latin typeface="Inter"/>
+              </a:rPr>
+              <a:t>Regressão no BetAki</a:t>
+            </a:r>
+          </a:p>
+        </p:txBody>
+      </p:sp>
+      <p:sp>
+        <p:nvSpPr>
+          <p:cNvPr id="11" name="TextBox 10"/>
+          <p:cNvSpPr txBox="1"/>
+          <p:nvPr/>
+        </p:nvSpPr>
+        <p:spPr>
+          <a:xfrm>
+            <a:off x="4023360" y="3840480"/>
+            <a:ext cx="7498079" cy="822960"/>
+          </a:xfrm>
+          <a:prstGeom prst="rect">
+            <a:avLst/>
+          </a:prstGeom>
+          <a:noFill/>
+        </p:spPr>
+        <p:txBody>
+          <a:bodyPr wrap="square">
+            <a:spAutoFit/>
+          </a:bodyPr>
+          <a:lstStyle/>
+          <a:p>
+            <a:pPr algn="l">
+              <a:lnSpc>
+                <a:spcPct val="130000"/>
+              </a:lnSpc>
+            </a:pPr>
+            <a:r>
+              <a:rPr sz="1400" b="0">
+                <a:solidFill>
+                  <a:srgbClr val="ECE7F7"/>
+                </a:solidFill>
+                <a:latin typeface="Inter"/>
+              </a:rPr>
+              <a:t>White-label feito com o BetAki como marca 1 e comparação visual antes de qualquer merge.</a:t>
+            </a:r>
+          </a:p>
+        </p:txBody>
+      </p:sp>
+      <p:sp>
+        <p:nvSpPr>
+          <p:cNvPr id="12" name="TextBox 11"/>
+          <p:cNvSpPr txBox="1"/>
+          <p:nvPr/>
+        </p:nvSpPr>
+        <p:spPr>
+          <a:xfrm>
+            <a:off x="731520" y="4754880"/>
+            <a:ext cx="3108960" cy="822960"/>
+          </a:xfrm>
+          <a:prstGeom prst="rect">
+            <a:avLst/>
+          </a:prstGeom>
+          <a:noFill/>
+        </p:spPr>
+        <p:txBody>
+          <a:bodyPr wrap="square">
+            <a:spAutoFit/>
+          </a:bodyPr>
+          <a:lstStyle/>
+          <a:p>
+            <a:pPr algn="l">
+              <a:lnSpc>
+                <a:spcPct val="115000"/>
+              </a:lnSpc>
+            </a:pPr>
+            <a:r>
+              <a:rPr sz="1500" b="1">
+                <a:solidFill>
+                  <a:srgbClr val="E145FF"/>
+                </a:solidFill>
+                <a:latin typeface="Inter"/>
+              </a:rPr>
+              <a:t>Escopo crescendo</a:t>
+            </a:r>
+          </a:p>
+        </p:txBody>
+      </p:sp>
+      <p:sp>
+        <p:nvSpPr>
+          <p:cNvPr id="13" name="TextBox 12"/>
+          <p:cNvSpPr txBox="1"/>
+          <p:nvPr/>
+        </p:nvSpPr>
+        <p:spPr>
+          <a:xfrm>
+            <a:off x="4023360" y="4754880"/>
+            <a:ext cx="7498079" cy="822960"/>
+          </a:xfrm>
+          <a:prstGeom prst="rect">
+            <a:avLst/>
+          </a:prstGeom>
+          <a:noFill/>
+        </p:spPr>
+        <p:txBody>
+          <a:bodyPr wrap="square">
+            <a:spAutoFit/>
+          </a:bodyPr>
+          <a:lstStyle/>
+          <a:p>
+            <a:pPr algn="l">
+              <a:lnSpc>
+                <a:spcPct val="130000"/>
+              </a:lnSpc>
+            </a:pPr>
+            <a:r>
+              <a:rPr sz="1400" b="0">
+                <a:solidFill>
+                  <a:srgbClr val="ECE7F7"/>
+                </a:solidFill>
+                <a:latin typeface="Inter"/>
+              </a:rPr>
+              <a:t>Tudo fora da tabela de fases entra como fase 6, negociada à parte.</a:t>
+            </a:r>
+          </a:p>
+        </p:txBody>
+      </p:sp>
+    </p:spTree>
+  </p:cSld>
+  <p:clrMapOvr>
+    <a:masterClrMapping/>
+  </p:clrMapOvr>
+</p:sld>
+</file>
+
+<file path=ppt/slides/slide11.xml><?xml version="1.0" encoding="utf-8"?>
+<p:sld xmlns:a="http://schemas.openxmlformats.org/drawingml/2006/main" xmlns:p="http://schemas.openxmlformats.org/presentationml/2006/main" xmlns:r="http://schemas.openxmlformats.org/officeDocument/2006/relationships">
+  <p:cSld>
+    <p:bg>
+      <p:bgPr>
+        <a:solidFill>
+          <a:srgbClr val="07020F"/>
+        </a:solidFill>
+        <a:effectLst/>
+      </p:bgPr>
+    </p:bg>
+    <p:spTree>
+      <p:nvGrpSpPr>
+        <p:cNvPr id="1" name=""/>
+        <p:cNvGrpSpPr/>
+        <p:nvPr/>
+      </p:nvGrpSpPr>
+      <p:grpSpPr/>
+      <p:sp>
+        <p:nvSpPr>
+          <p:cNvPr id="2" name="TextBox 1"/>
+          <p:cNvSpPr txBox="1"/>
+          <p:nvPr/>
+        </p:nvSpPr>
+        <p:spPr>
+          <a:xfrm>
+            <a:off x="548640" y="6400800"/>
+            <a:ext cx="5486400" cy="274320"/>
+          </a:xfrm>
+          <a:prstGeom prst="rect">
+            <a:avLst/>
+          </a:prstGeom>
+          <a:noFill/>
+        </p:spPr>
+        <p:txBody>
+          <a:bodyPr wrap="square">
+            <a:spAutoFit/>
+          </a:bodyPr>
+          <a:lstStyle/>
+          <a:p>
+            <a:pPr algn="l">
+              <a:lnSpc>
+                <a:spcPct val="115000"/>
+              </a:lnSpc>
+            </a:pPr>
+            <a:r>
+              <a:rPr sz="900" b="0">
+                <a:solidFill>
+                  <a:srgbClr val="9A90B8"/>
+                </a:solidFill>
+                <a:latin typeface="Inter"/>
+              </a:rPr>
+              <a:t>GirosBet v2 · proposta técnica · rascunho v0.1</a:t>
+            </a:r>
+          </a:p>
+        </p:txBody>
+      </p:sp>
+      <p:sp>
+        <p:nvSpPr>
+          <p:cNvPr id="3" name="TextBox 2"/>
+          <p:cNvSpPr txBox="1"/>
+          <p:nvPr/>
+        </p:nvSpPr>
+        <p:spPr>
+          <a:xfrm>
+            <a:off x="10728655" y="6400800"/>
+            <a:ext cx="914400" cy="274320"/>
+          </a:xfrm>
+          <a:prstGeom prst="rect">
+            <a:avLst/>
+          </a:prstGeom>
+          <a:noFill/>
+        </p:spPr>
+        <p:txBody>
+          <a:bodyPr wrap="square">
+            <a:spAutoFit/>
+          </a:bodyPr>
+          <a:lstStyle/>
+          <a:p>
+            <a:pPr algn="r">
+              <a:lnSpc>
+                <a:spcPct val="115000"/>
+              </a:lnSpc>
+            </a:pPr>
+            <a:r>
+              <a:rPr sz="900" b="0">
+                <a:solidFill>
+                  <a:srgbClr val="9A90B8"/>
+                </a:solidFill>
+                <a:latin typeface="Inter"/>
+              </a:rPr>
+              <a:t>11</a:t>
+            </a:r>
+          </a:p>
+        </p:txBody>
+      </p:sp>
+      <p:sp>
+        <p:nvSpPr>
+          <p:cNvPr id="4" name="TextBox 3"/>
+          <p:cNvSpPr txBox="1"/>
+          <p:nvPr/>
+        </p:nvSpPr>
+        <p:spPr>
+          <a:xfrm>
+            <a:off x="731520" y="548640"/>
+            <a:ext cx="7315200" cy="365760"/>
+          </a:xfrm>
+          <a:prstGeom prst="rect">
+            <a:avLst/>
+          </a:prstGeom>
+          <a:noFill/>
+        </p:spPr>
+        <p:txBody>
+          <a:bodyPr wrap="square">
+            <a:spAutoFit/>
+          </a:bodyPr>
+          <a:lstStyle/>
+          <a:p>
+            <a:pPr algn="l">
+              <a:lnSpc>
+                <a:spcPct val="115000"/>
+              </a:lnSpc>
+            </a:pPr>
+            <a:r>
+              <a:rPr sz="1100" b="1">
+                <a:solidFill>
+                  <a:srgbClr val="E145FF"/>
+                </a:solidFill>
+                <a:latin typeface="Inter"/>
+              </a:rPr>
               <a:t>PRÓXIMOS PASSOS</a:t>
             </a:r>
           </a:p>
@@ -5587,7 +6082,7 @@
                 </a:solidFill>
                 <a:latin typeface="Inter"/>
               </a:rPr>
-              <a:t>ESCOPO</a:t>
+              <a:t>LAYOUT</a:t>
             </a:r>
           </a:p>
         </p:txBody>
@@ -5626,7 +6121,7 @@
                 </a:solidFill>
                 <a:latin typeface="Bebas Neue"/>
               </a:rPr>
-              <a:t>Seis fases</a:t>
+              <a:t>Trazer a v1 para dentro da label</a:t>
             </a:r>
           </a:p>
         </p:txBody>
@@ -5639,33 +6134,33 @@
         </p:nvSpPr>
         <p:spPr>
           <a:xfrm>
-            <a:off x="731520" y="2011680"/>
-            <a:ext cx="548640" cy="457200"/>
-          </a:xfrm>
-          <a:prstGeom prst="rect">
-            <a:avLst/>
-          </a:prstGeom>
-          <a:noFill/>
-        </p:spPr>
-        <p:txBody>
-          <a:bodyPr wrap="square">
-            <a:spAutoFit/>
-          </a:bodyPr>
-          <a:lstStyle/>
-          <a:p>
-            <a:pPr algn="l">
-              <a:lnSpc>
-                <a:spcPct val="100000"/>
-              </a:lnSpc>
-            </a:pPr>
-            <a:r>
-              <a:rPr sz="2800" b="0">
+            <a:off x="731520" y="1965960"/>
+            <a:ext cx="5394960" cy="365760"/>
+          </a:xfrm>
+          <a:prstGeom prst="rect">
+            <a:avLst/>
+          </a:prstGeom>
+          <a:noFill/>
+        </p:spPr>
+        <p:txBody>
+          <a:bodyPr wrap="square">
+            <a:spAutoFit/>
+          </a:bodyPr>
+          <a:lstStyle/>
+          <a:p>
+            <a:pPr algn="l">
+              <a:lnSpc>
+                <a:spcPct val="115000"/>
+              </a:lnSpc>
+            </a:pPr>
+            <a:r>
+              <a:rPr sz="1400" b="1">
                 <a:solidFill>
                   <a:srgbClr val="E145FF"/>
                 </a:solidFill>
-                <a:latin typeface="Bebas Neue"/>
-              </a:rPr>
-              <a:t>0</a:t>
+                <a:latin typeface="Inter"/>
+              </a:rPr>
+              <a:t>Header escuro</a:t>
             </a:r>
           </a:p>
         </p:txBody>
@@ -5678,8 +6173,47 @@
         </p:nvSpPr>
         <p:spPr>
           <a:xfrm>
-            <a:off x="1371600" y="2057400"/>
-            <a:ext cx="2377440" cy="457200"/>
+            <a:off x="731520" y="2313432"/>
+            <a:ext cx="5394960" cy="640080"/>
+          </a:xfrm>
+          <a:prstGeom prst="rect">
+            <a:avLst/>
+          </a:prstGeom>
+          <a:noFill/>
+        </p:spPr>
+        <p:txBody>
+          <a:bodyPr wrap="square">
+            <a:spAutoFit/>
+          </a:bodyPr>
+          <a:lstStyle/>
+          <a:p>
+            <a:pPr algn="l">
+              <a:lnSpc>
+                <a:spcPct val="125000"/>
+              </a:lnSpc>
+            </a:pPr>
+            <a:r>
+              <a:rPr sz="1200" b="0">
+                <a:solidFill>
+                  <a:srgbClr val="9A90B8"/>
+                </a:solidFill>
+                <a:latin typeface="Inter"/>
+              </a:rPr>
+              <a:t>Toggle Cassino / Esportes, busca inline, 'Criar Conta' magenta. Roxo como acento.</a:t>
+            </a:r>
+          </a:p>
+        </p:txBody>
+      </p:sp>
+      <p:sp>
+        <p:nvSpPr>
+          <p:cNvPr id="8" name="TextBox 7"/>
+          <p:cNvSpPr txBox="1"/>
+          <p:nvPr/>
+        </p:nvSpPr>
+        <p:spPr>
+          <a:xfrm>
+            <a:off x="6400800" y="1965960"/>
+            <a:ext cx="5394960" cy="365760"/>
           </a:xfrm>
           <a:prstGeom prst="rect">
             <a:avLst/>
@@ -5698,27 +6232,66 @@
               </a:lnSpc>
             </a:pPr>
             <a:r>
-              <a:rPr sz="1500" b="1">
-                <a:solidFill>
-                  <a:srgbClr val="ECE7F7"/>
-                </a:solidFill>
-                <a:latin typeface="Inter"/>
-              </a:rPr>
-              <a:t>Fundação</a:t>
-            </a:r>
-          </a:p>
-        </p:txBody>
-      </p:sp>
-      <p:sp>
-        <p:nvSpPr>
-          <p:cNvPr id="8" name="TextBox 7"/>
-          <p:cNvSpPr txBox="1"/>
-          <p:nvPr/>
-        </p:nvSpPr>
-        <p:spPr>
-          <a:xfrm>
-            <a:off x="3840480" y="2057400"/>
-            <a:ext cx="5852160" cy="457200"/>
+              <a:rPr sz="1400" b="1">
+                <a:solidFill>
+                  <a:srgbClr val="E145FF"/>
+                </a:solidFill>
+                <a:latin typeface="Inter"/>
+              </a:rPr>
+              <a:t>Sidebar da v1 de volta</a:t>
+            </a:r>
+          </a:p>
+        </p:txBody>
+      </p:sp>
+      <p:sp>
+        <p:nvSpPr>
+          <p:cNvPr id="9" name="TextBox 8"/>
+          <p:cNvSpPr txBox="1"/>
+          <p:nvPr/>
+        </p:nvSpPr>
+        <p:spPr>
+          <a:xfrm>
+            <a:off x="6400800" y="2313432"/>
+            <a:ext cx="5394960" cy="640080"/>
+          </a:xfrm>
+          <a:prstGeom prst="rect">
+            <a:avLst/>
+          </a:prstGeom>
+          <a:noFill/>
+        </p:spPr>
+        <p:txBody>
+          <a:bodyPr wrap="square">
+            <a:spAutoFit/>
+          </a:bodyPr>
+          <a:lstStyle/>
+          <a:p>
+            <a:pPr algn="l">
+              <a:lnSpc>
+                <a:spcPct val="125000"/>
+              </a:lnSpc>
+            </a:pPr>
+            <a:r>
+              <a:rPr sz="1200" b="0">
+                <a:solidFill>
+                  <a:srgbClr val="9A90B8"/>
+                </a:solidFill>
+                <a:latin typeface="Inter"/>
+              </a:rPr>
+              <a:t>Banner, tiles Cupom / Promo, atalhos, populares e suporte, via CMS.</a:t>
+            </a:r>
+          </a:p>
+        </p:txBody>
+      </p:sp>
+      <p:sp>
+        <p:nvSpPr>
+          <p:cNvPr id="10" name="TextBox 9"/>
+          <p:cNvSpPr txBox="1"/>
+          <p:nvPr/>
+        </p:nvSpPr>
+        <p:spPr>
+          <a:xfrm>
+            <a:off x="731520" y="3017520"/>
+            <a:ext cx="5394960" cy="365760"/>
           </a:xfrm>
           <a:prstGeom prst="rect">
             <a:avLst/>
@@ -5737,148 +6310,222 @@
               </a:lnSpc>
             </a:pPr>
             <a:r>
-              <a:rPr sz="1300" b="0">
+              <a:rPr sz="1400" b="1">
+                <a:solidFill>
+                  <a:srgbClr val="E145FF"/>
+                </a:solidFill>
+                <a:latin typeface="Inter"/>
+              </a:rPr>
+              <a:t>Topbar de cupom e ticker no topo</a:t>
+            </a:r>
+          </a:p>
+        </p:txBody>
+      </p:sp>
+      <p:sp>
+        <p:nvSpPr>
+          <p:cNvPr id="11" name="TextBox 10"/>
+          <p:cNvSpPr txBox="1"/>
+          <p:nvPr/>
+        </p:nvSpPr>
+        <p:spPr>
+          <a:xfrm>
+            <a:off x="731520" y="3364992"/>
+            <a:ext cx="5394960" cy="640080"/>
+          </a:xfrm>
+          <a:prstGeom prst="rect">
+            <a:avLst/>
+          </a:prstGeom>
+          <a:noFill/>
+        </p:spPr>
+        <p:txBody>
+          <a:bodyPr wrap="square">
+            <a:spAutoFit/>
+          </a:bodyPr>
+          <a:lstStyle/>
+          <a:p>
+            <a:pPr algn="l">
+              <a:lnSpc>
+                <a:spcPct val="125000"/>
+              </a:lnSpc>
+            </a:pPr>
+            <a:r>
+              <a:rPr sz="1200" b="0">
                 <a:solidFill>
                   <a:srgbClr val="9A90B8"/>
                 </a:solidFill>
                 <a:latin typeface="Inter"/>
               </a:rPr>
-              <a:t>tooling, white-label, BetAki como marca 1 sem regressão</a:t>
-            </a:r>
-          </a:p>
-        </p:txBody>
-      </p:sp>
-      <p:sp>
-        <p:nvSpPr>
-          <p:cNvPr id="9" name="TextBox 8"/>
-          <p:cNvSpPr txBox="1"/>
-          <p:nvPr/>
-        </p:nvSpPr>
-        <p:spPr>
-          <a:xfrm>
-            <a:off x="9875520" y="2057400"/>
-            <a:ext cx="1737360" cy="457200"/>
-          </a:xfrm>
-          <a:prstGeom prst="rect">
-            <a:avLst/>
-          </a:prstGeom>
-          <a:noFill/>
-        </p:spPr>
-        <p:txBody>
-          <a:bodyPr wrap="square">
-            <a:spAutoFit/>
-          </a:bodyPr>
-          <a:lstStyle/>
-          <a:p>
-            <a:pPr algn="r">
+              <a:t>Os recursos de aquisição da v1 que a label perdeu, via CMS.</a:t>
+            </a:r>
+          </a:p>
+        </p:txBody>
+      </p:sp>
+      <p:sp>
+        <p:nvSpPr>
+          <p:cNvPr id="12" name="TextBox 11"/>
+          <p:cNvSpPr txBox="1"/>
+          <p:nvPr/>
+        </p:nvSpPr>
+        <p:spPr>
+          <a:xfrm>
+            <a:off x="6400800" y="3017520"/>
+            <a:ext cx="5394960" cy="365760"/>
+          </a:xfrm>
+          <a:prstGeom prst="rect">
+            <a:avLst/>
+          </a:prstGeom>
+          <a:noFill/>
+        </p:spPr>
+        <p:txBody>
+          <a:bodyPr wrap="square">
+            <a:spAutoFit/>
+          </a:bodyPr>
+          <a:lstStyle/>
+          <a:p>
+            <a:pPr algn="l">
               <a:lnSpc>
                 <a:spcPct val="115000"/>
               </a:lnSpc>
             </a:pPr>
             <a:r>
+              <a:rPr sz="1400" b="1">
+                <a:solidFill>
+                  <a:srgbClr val="E145FF"/>
+                </a:solidFill>
+                <a:latin typeface="Inter"/>
+              </a:rPr>
+              <a:t>Hero menor</a:t>
+            </a:r>
+          </a:p>
+        </p:txBody>
+      </p:sp>
+      <p:sp>
+        <p:nvSpPr>
+          <p:cNvPr id="13" name="TextBox 12"/>
+          <p:cNvSpPr txBox="1"/>
+          <p:nvPr/>
+        </p:nvSpPr>
+        <p:spPr>
+          <a:xfrm>
+            <a:off x="6400800" y="3364992"/>
+            <a:ext cx="5394960" cy="640080"/>
+          </a:xfrm>
+          <a:prstGeom prst="rect">
+            <a:avLst/>
+          </a:prstGeom>
+          <a:noFill/>
+        </p:spPr>
+        <p:txBody>
+          <a:bodyPr wrap="square">
+            <a:spAutoFit/>
+          </a:bodyPr>
+          <a:lstStyle/>
+          <a:p>
+            <a:pPr algn="l">
+              <a:lnSpc>
+                <a:spcPct val="125000"/>
+              </a:lnSpc>
+            </a:pPr>
+            <a:r>
               <a:rPr sz="1200" b="0">
                 <a:solidFill>
-                  <a:srgbClr val="ECE7F7"/>
-                </a:solidFill>
-                <a:latin typeface="Inter"/>
-              </a:rPr>
-              <a:t>feito</a:t>
-            </a:r>
-          </a:p>
-        </p:txBody>
-      </p:sp>
-      <p:sp>
-        <p:nvSpPr>
-          <p:cNvPr id="10" name="Rectangle 9"/>
-          <p:cNvSpPr/>
-          <p:nvPr/>
-        </p:nvSpPr>
-        <p:spPr>
-          <a:xfrm>
-            <a:off x="731520" y="2578608"/>
-            <a:ext cx="10881360" cy="12700"/>
-          </a:xfrm>
-          <a:prstGeom prst="rect">
-            <a:avLst/>
-          </a:prstGeom>
-          <a:solidFill>
-            <a:srgbClr val="2A1547"/>
-          </a:solidFill>
-          <a:ln>
-            <a:noFill/>
-          </a:ln>
-        </p:spPr>
-        <p:style>
-          <a:lnRef idx="1">
-            <a:schemeClr val="accent1"/>
-          </a:lnRef>
-          <a:fillRef idx="3">
-            <a:schemeClr val="accent1"/>
-          </a:fillRef>
-          <a:effectRef idx="2">
-            <a:schemeClr val="accent1"/>
-          </a:effectRef>
-          <a:fontRef idx="minor">
-            <a:schemeClr val="lt1"/>
-          </a:fontRef>
-        </p:style>
-        <p:txBody>
-          <a:bodyPr rtlCol="0" anchor="ctr"/>
-          <a:lstStyle/>
-          <a:p>
-            <a:pPr algn="ctr"/>
-          </a:p>
-        </p:txBody>
-      </p:sp>
-      <p:sp>
-        <p:nvSpPr>
-          <p:cNvPr id="11" name="TextBox 10"/>
-          <p:cNvSpPr txBox="1"/>
-          <p:nvPr/>
-        </p:nvSpPr>
-        <p:spPr>
-          <a:xfrm>
-            <a:off x="731520" y="2670048"/>
-            <a:ext cx="548640" cy="457200"/>
-          </a:xfrm>
-          <a:prstGeom prst="rect">
-            <a:avLst/>
-          </a:prstGeom>
-          <a:noFill/>
-        </p:spPr>
-        <p:txBody>
-          <a:bodyPr wrap="square">
-            <a:spAutoFit/>
-          </a:bodyPr>
-          <a:lstStyle/>
-          <a:p>
-            <a:pPr algn="l">
-              <a:lnSpc>
-                <a:spcPct val="100000"/>
-              </a:lnSpc>
-            </a:pPr>
-            <a:r>
-              <a:rPr sz="2800" b="0">
+                  <a:srgbClr val="9A90B8"/>
+                </a:solidFill>
+                <a:latin typeface="Inter"/>
+              </a:rPr>
+              <a:t>Um slide visível, CTA e selos na arte; catálogo na primeira tela.</a:t>
+            </a:r>
+          </a:p>
+        </p:txBody>
+      </p:sp>
+      <p:sp>
+        <p:nvSpPr>
+          <p:cNvPr id="14" name="TextBox 13"/>
+          <p:cNvSpPr txBox="1"/>
+          <p:nvPr/>
+        </p:nvSpPr>
+        <p:spPr>
+          <a:xfrm>
+            <a:off x="731520" y="4069079"/>
+            <a:ext cx="5394960" cy="365760"/>
+          </a:xfrm>
+          <a:prstGeom prst="rect">
+            <a:avLst/>
+          </a:prstGeom>
+          <a:noFill/>
+        </p:spPr>
+        <p:txBody>
+          <a:bodyPr wrap="square">
+            <a:spAutoFit/>
+          </a:bodyPr>
+          <a:lstStyle/>
+          <a:p>
+            <a:pPr algn="l">
+              <a:lnSpc>
+                <a:spcPct val="115000"/>
+              </a:lnSpc>
+            </a:pPr>
+            <a:r>
+              <a:rPr sz="1400" b="1">
                 <a:solidFill>
                   <a:srgbClr val="E145FF"/>
                 </a:solidFill>
-                <a:latin typeface="Bebas Neue"/>
-              </a:rPr>
-              <a:t>1</a:t>
-            </a:r>
-          </a:p>
-        </p:txBody>
-      </p:sp>
-      <p:sp>
-        <p:nvSpPr>
-          <p:cNvPr id="12" name="TextBox 11"/>
-          <p:cNvSpPr txBox="1"/>
-          <p:nvPr/>
-        </p:nvSpPr>
-        <p:spPr>
-          <a:xfrm>
-            <a:off x="1371600" y="2715768"/>
-            <a:ext cx="2377440" cy="457200"/>
+                <a:latin typeface="Inter"/>
+              </a:rPr>
+              <a:t>Chips com ícone e seções com ritmo</a:t>
+            </a:r>
+          </a:p>
+        </p:txBody>
+      </p:sp>
+      <p:sp>
+        <p:nvSpPr>
+          <p:cNvPr id="15" name="TextBox 14"/>
+          <p:cNvSpPr txBox="1"/>
+          <p:nvPr/>
+        </p:nvSpPr>
+        <p:spPr>
+          <a:xfrm>
+            <a:off x="731520" y="4416551"/>
+            <a:ext cx="5394960" cy="640080"/>
+          </a:xfrm>
+          <a:prstGeom prst="rect">
+            <a:avLst/>
+          </a:prstGeom>
+          <a:noFill/>
+        </p:spPr>
+        <p:txBody>
+          <a:bodyPr wrap="square">
+            <a:spAutoFit/>
+          </a:bodyPr>
+          <a:lstStyle/>
+          <a:p>
+            <a:pPr algn="l">
+              <a:lnSpc>
+                <a:spcPct val="125000"/>
+              </a:lnSpc>
+            </a:pPr>
+            <a:r>
+              <a:rPr sz="1200" b="0">
+                <a:solidFill>
+                  <a:srgbClr val="9A90B8"/>
+                </a:solidFill>
+                <a:latin typeface="Inter"/>
+              </a:rPr>
+              <a:t>Categorias com ícone; cabeçalho com ícone, setas e 'Ver todos'.</a:t>
+            </a:r>
+          </a:p>
+        </p:txBody>
+      </p:sp>
+      <p:sp>
+        <p:nvSpPr>
+          <p:cNvPr id="16" name="TextBox 15"/>
+          <p:cNvSpPr txBox="1"/>
+          <p:nvPr/>
+        </p:nvSpPr>
+        <p:spPr>
+          <a:xfrm>
+            <a:off x="6400800" y="4069079"/>
+            <a:ext cx="5394960" cy="365760"/>
           </a:xfrm>
           <a:prstGeom prst="rect">
             <a:avLst/>
@@ -5897,27 +6544,66 @@
               </a:lnSpc>
             </a:pPr>
             <a:r>
-              <a:rPr sz="1500" b="1">
-                <a:solidFill>
-                  <a:srgbClr val="ECE7F7"/>
-                </a:solidFill>
-                <a:latin typeface="Inter"/>
-              </a:rPr>
-              <a:t>Marca GirosBet</a:t>
-            </a:r>
-          </a:p>
-        </p:txBody>
-      </p:sp>
-      <p:sp>
-        <p:nvSpPr>
-          <p:cNvPr id="13" name="TextBox 12"/>
-          <p:cNvSpPr txBox="1"/>
-          <p:nvPr/>
-        </p:nvSpPr>
-        <p:spPr>
-          <a:xfrm>
-            <a:off x="3840480" y="2715768"/>
-            <a:ext cx="5852160" cy="457200"/>
+              <a:rPr sz="1400" b="1">
+                <a:solidFill>
+                  <a:srgbClr val="E145FF"/>
+                </a:solidFill>
+                <a:latin typeface="Inter"/>
+              </a:rPr>
+              <a:t>Cards e provedores como na v1</a:t>
+            </a:r>
+          </a:p>
+        </p:txBody>
+      </p:sp>
+      <p:sp>
+        <p:nvSpPr>
+          <p:cNvPr id="17" name="TextBox 16"/>
+          <p:cNvSpPr txBox="1"/>
+          <p:nvPr/>
+        </p:nvSpPr>
+        <p:spPr>
+          <a:xfrm>
+            <a:off x="6400800" y="4416551"/>
+            <a:ext cx="5394960" cy="640080"/>
+          </a:xfrm>
+          <a:prstGeom prst="rect">
+            <a:avLst/>
+          </a:prstGeom>
+          <a:noFill/>
+        </p:spPr>
+        <p:txBody>
+          <a:bodyPr wrap="square">
+            <a:spAutoFit/>
+          </a:bodyPr>
+          <a:lstStyle/>
+          <a:p>
+            <a:pPr algn="l">
+              <a:lnSpc>
+                <a:spcPct val="125000"/>
+              </a:lnSpc>
+            </a:pPr>
+            <a:r>
+              <a:rPr sz="1200" b="0">
+                <a:solidFill>
+                  <a:srgbClr val="9A90B8"/>
+                </a:solidFill>
+                <a:latin typeface="Inter"/>
+              </a:rPr>
+              <a:t>Provedor no card, 'Jogar agora' no hover; provedores em card escuro.</a:t>
+            </a:r>
+          </a:p>
+        </p:txBody>
+      </p:sp>
+      <p:sp>
+        <p:nvSpPr>
+          <p:cNvPr id="18" name="TextBox 17"/>
+          <p:cNvSpPr txBox="1"/>
+          <p:nvPr/>
+        </p:nvSpPr>
+        <p:spPr>
+          <a:xfrm>
+            <a:off x="731520" y="5120640"/>
+            <a:ext cx="5394960" cy="365760"/>
           </a:xfrm>
           <a:prstGeom prst="rect">
             <a:avLst/>
@@ -5936,930 +6622,130 @@
               </a:lnSpc>
             </a:pPr>
             <a:r>
-              <a:rPr sz="1300" b="0">
+              <a:rPr sz="1400" b="1">
+                <a:solidFill>
+                  <a:srgbClr val="E145FF"/>
+                </a:solidFill>
+                <a:latin typeface="Inter"/>
+              </a:rPr>
+              <a:t>Mobile enxuto</a:t>
+            </a:r>
+          </a:p>
+        </p:txBody>
+      </p:sp>
+      <p:sp>
+        <p:nvSpPr>
+          <p:cNvPr id="19" name="TextBox 18"/>
+          <p:cNvSpPr txBox="1"/>
+          <p:nvPr/>
+        </p:nvSpPr>
+        <p:spPr>
+          <a:xfrm>
+            <a:off x="731520" y="5468112"/>
+            <a:ext cx="5394960" cy="640080"/>
+          </a:xfrm>
+          <a:prstGeom prst="rect">
+            <a:avLst/>
+          </a:prstGeom>
+          <a:noFill/>
+        </p:spPr>
+        <p:txBody>
+          <a:bodyPr wrap="square">
+            <a:spAutoFit/>
+          </a:bodyPr>
+          <a:lstStyle/>
+          <a:p>
+            <a:pPr algn="l">
+              <a:lnSpc>
+                <a:spcPct val="125000"/>
+              </a:lnSpc>
+            </a:pPr>
+            <a:r>
+              <a:rPr sz="1200" b="0">
                 <a:solidFill>
                   <a:srgbClr val="9A90B8"/>
                 </a:solidFill>
                 <a:latin typeface="Inter"/>
               </a:rPr>
-              <a:t>pacote de marca, home, lobbies, busca, header, sidebar, footer</a:t>
-            </a:r>
-          </a:p>
-        </p:txBody>
-      </p:sp>
-      <p:sp>
-        <p:nvSpPr>
-          <p:cNvPr id="14" name="TextBox 13"/>
-          <p:cNvSpPr txBox="1"/>
-          <p:nvPr/>
-        </p:nvSpPr>
-        <p:spPr>
-          <a:xfrm>
-            <a:off x="9875520" y="2715768"/>
-            <a:ext cx="1737360" cy="457200"/>
-          </a:xfrm>
-          <a:prstGeom prst="rect">
-            <a:avLst/>
-          </a:prstGeom>
-          <a:noFill/>
-        </p:spPr>
-        <p:txBody>
-          <a:bodyPr wrap="square">
-            <a:spAutoFit/>
-          </a:bodyPr>
-          <a:lstStyle/>
-          <a:p>
-            <a:pPr algn="r">
+              <a:t>Header compacto, barra inferior com 5 itens e ícone da marca, grade 4 por linha.</a:t>
+            </a:r>
+          </a:p>
+        </p:txBody>
+      </p:sp>
+      <p:sp>
+        <p:nvSpPr>
+          <p:cNvPr id="20" name="TextBox 19"/>
+          <p:cNvSpPr txBox="1"/>
+          <p:nvPr/>
+        </p:nvSpPr>
+        <p:spPr>
+          <a:xfrm>
+            <a:off x="6400800" y="5120640"/>
+            <a:ext cx="5394960" cy="365760"/>
+          </a:xfrm>
+          <a:prstGeom prst="rect">
+            <a:avLst/>
+          </a:prstGeom>
+          <a:noFill/>
+        </p:spPr>
+        <p:txBody>
+          <a:bodyPr wrap="square">
+            <a:spAutoFit/>
+          </a:bodyPr>
+          <a:lstStyle/>
+          <a:p>
+            <a:pPr algn="l">
               <a:lnSpc>
                 <a:spcPct val="115000"/>
               </a:lnSpc>
             </a:pPr>
             <a:r>
+              <a:rPr sz="1400" b="1">
+                <a:solidFill>
+                  <a:srgbClr val="E145FF"/>
+                </a:solidFill>
+                <a:latin typeface="Inter"/>
+              </a:rPr>
+              <a:t>Entrada e rodapé</a:t>
+            </a:r>
+          </a:p>
+        </p:txBody>
+      </p:sp>
+      <p:sp>
+        <p:nvSpPr>
+          <p:cNvPr id="21" name="TextBox 20"/>
+          <p:cNvSpPr txBox="1"/>
+          <p:nvPr/>
+        </p:nvSpPr>
+        <p:spPr>
+          <a:xfrm>
+            <a:off x="6400800" y="5468112"/>
+            <a:ext cx="5394960" cy="640080"/>
+          </a:xfrm>
+          <a:prstGeom prst="rect">
+            <a:avLst/>
+          </a:prstGeom>
+          <a:noFill/>
+        </p:spPr>
+        <p:txBody>
+          <a:bodyPr wrap="square">
+            <a:spAutoFit/>
+          </a:bodyPr>
+          <a:lstStyle/>
+          <a:p>
+            <a:pPr algn="l">
+              <a:lnSpc>
+                <a:spcPct val="125000"/>
+              </a:lnSpc>
+            </a:pPr>
+            <a:r>
               <a:rPr sz="1200" b="0">
                 <a:solidFill>
-                  <a:srgbClr val="ECE7F7"/>
-                </a:solidFill>
-                <a:latin typeface="Inter"/>
-              </a:rPr>
-              <a:t>em andamento</a:t>
-            </a:r>
-          </a:p>
-        </p:txBody>
-      </p:sp>
-      <p:sp>
-        <p:nvSpPr>
-          <p:cNvPr id="15" name="Rectangle 14"/>
-          <p:cNvSpPr/>
-          <p:nvPr/>
-        </p:nvSpPr>
-        <p:spPr>
-          <a:xfrm>
-            <a:off x="731520" y="3236976"/>
-            <a:ext cx="10881360" cy="12700"/>
-          </a:xfrm>
-          <a:prstGeom prst="rect">
-            <a:avLst/>
-          </a:prstGeom>
-          <a:solidFill>
-            <a:srgbClr val="2A1547"/>
-          </a:solidFill>
-          <a:ln>
-            <a:noFill/>
-          </a:ln>
-        </p:spPr>
-        <p:style>
-          <a:lnRef idx="1">
-            <a:schemeClr val="accent1"/>
-          </a:lnRef>
-          <a:fillRef idx="3">
-            <a:schemeClr val="accent1"/>
-          </a:fillRef>
-          <a:effectRef idx="2">
-            <a:schemeClr val="accent1"/>
-          </a:effectRef>
-          <a:fontRef idx="minor">
-            <a:schemeClr val="lt1"/>
-          </a:fontRef>
-        </p:style>
-        <p:txBody>
-          <a:bodyPr rtlCol="0" anchor="ctr"/>
-          <a:lstStyle/>
-          <a:p>
-            <a:pPr algn="ctr"/>
-          </a:p>
-        </p:txBody>
-      </p:sp>
-      <p:sp>
-        <p:nvSpPr>
-          <p:cNvPr id="16" name="TextBox 15"/>
-          <p:cNvSpPr txBox="1"/>
-          <p:nvPr/>
-        </p:nvSpPr>
-        <p:spPr>
-          <a:xfrm>
-            <a:off x="731520" y="3328416"/>
-            <a:ext cx="548640" cy="457200"/>
-          </a:xfrm>
-          <a:prstGeom prst="rect">
-            <a:avLst/>
-          </a:prstGeom>
-          <a:noFill/>
-        </p:spPr>
-        <p:txBody>
-          <a:bodyPr wrap="square">
-            <a:spAutoFit/>
-          </a:bodyPr>
-          <a:lstStyle/>
-          <a:p>
-            <a:pPr algn="l">
-              <a:lnSpc>
-                <a:spcPct val="100000"/>
-              </a:lnSpc>
-            </a:pPr>
-            <a:r>
-              <a:rPr sz="2800" b="0">
-                <a:solidFill>
-                  <a:srgbClr val="E145FF"/>
-                </a:solidFill>
-                <a:latin typeface="Bebas Neue"/>
-              </a:rPr>
-              <a:t>2</a:t>
-            </a:r>
-          </a:p>
-        </p:txBody>
-      </p:sp>
-      <p:sp>
-        <p:nvSpPr>
-          <p:cNvPr id="17" name="TextBox 16"/>
-          <p:cNvSpPr txBox="1"/>
-          <p:nvPr/>
-        </p:nvSpPr>
-        <p:spPr>
-          <a:xfrm>
-            <a:off x="1371600" y="3374136"/>
-            <a:ext cx="2377440" cy="457200"/>
-          </a:xfrm>
-          <a:prstGeom prst="rect">
-            <a:avLst/>
-          </a:prstGeom>
-          <a:noFill/>
-        </p:spPr>
-        <p:txBody>
-          <a:bodyPr wrap="square">
-            <a:spAutoFit/>
-          </a:bodyPr>
-          <a:lstStyle/>
-          <a:p>
-            <a:pPr algn="l">
-              <a:lnSpc>
-                <a:spcPct val="115000"/>
-              </a:lnSpc>
-            </a:pPr>
-            <a:r>
-              <a:rPr sz="1500" b="1">
-                <a:solidFill>
-                  <a:srgbClr val="ECE7F7"/>
-                </a:solidFill>
-                <a:latin typeface="Inter"/>
-              </a:rPr>
-              <a:t>CMS GirosBet</a:t>
-            </a:r>
-          </a:p>
-        </p:txBody>
-      </p:sp>
-      <p:sp>
-        <p:nvSpPr>
-          <p:cNvPr id="18" name="TextBox 17"/>
-          <p:cNvSpPr txBox="1"/>
-          <p:nvPr/>
-        </p:nvSpPr>
-        <p:spPr>
-          <a:xfrm>
-            <a:off x="3840480" y="3374136"/>
-            <a:ext cx="5852160" cy="457200"/>
-          </a:xfrm>
-          <a:prstGeom prst="rect">
-            <a:avLst/>
-          </a:prstGeom>
-          <a:noFill/>
-        </p:spPr>
-        <p:txBody>
-          <a:bodyPr wrap="square">
-            <a:spAutoFit/>
-          </a:bodyPr>
-          <a:lstStyle/>
-          <a:p>
-            <a:pPr algn="l">
-              <a:lnSpc>
-                <a:spcPct val="115000"/>
-              </a:lnSpc>
-            </a:pPr>
-            <a:r>
-              <a:rPr sz="1300" b="0">
-                <a:solidFill>
                   <a:srgbClr val="9A90B8"/>
                 </a:solidFill>
                 <a:latin typeface="Inter"/>
               </a:rPr>
-              <a:t>instância própria, importação de catálogo, menus, banners, carrosséis</a:t>
-            </a:r>
-          </a:p>
-        </p:txBody>
-      </p:sp>
-      <p:sp>
-        <p:nvSpPr>
-          <p:cNvPr id="19" name="TextBox 18"/>
-          <p:cNvSpPr txBox="1"/>
-          <p:nvPr/>
-        </p:nvSpPr>
-        <p:spPr>
-          <a:xfrm>
-            <a:off x="9875520" y="3374136"/>
-            <a:ext cx="1737360" cy="457200"/>
-          </a:xfrm>
-          <a:prstGeom prst="rect">
-            <a:avLst/>
-          </a:prstGeom>
-          <a:noFill/>
-        </p:spPr>
-        <p:txBody>
-          <a:bodyPr wrap="square">
-            <a:spAutoFit/>
-          </a:bodyPr>
-          <a:lstStyle/>
-          <a:p>
-            <a:pPr algn="r">
-              <a:lnSpc>
-                <a:spcPct val="115000"/>
-              </a:lnSpc>
-            </a:pPr>
-            <a:r>
-              <a:rPr sz="1200" b="0">
-                <a:solidFill>
-                  <a:srgbClr val="ECE7F7"/>
-                </a:solidFill>
-                <a:latin typeface="Inter"/>
-              </a:rPr>
-              <a:t>[prazo]</a:t>
-            </a:r>
-          </a:p>
-        </p:txBody>
-      </p:sp>
-      <p:sp>
-        <p:nvSpPr>
-          <p:cNvPr id="20" name="Rectangle 19"/>
-          <p:cNvSpPr/>
-          <p:nvPr/>
-        </p:nvSpPr>
-        <p:spPr>
-          <a:xfrm>
-            <a:off x="731520" y="3895344"/>
-            <a:ext cx="10881360" cy="12700"/>
-          </a:xfrm>
-          <a:prstGeom prst="rect">
-            <a:avLst/>
-          </a:prstGeom>
-          <a:solidFill>
-            <a:srgbClr val="2A1547"/>
-          </a:solidFill>
-          <a:ln>
-            <a:noFill/>
-          </a:ln>
-        </p:spPr>
-        <p:style>
-          <a:lnRef idx="1">
-            <a:schemeClr val="accent1"/>
-          </a:lnRef>
-          <a:fillRef idx="3">
-            <a:schemeClr val="accent1"/>
-          </a:fillRef>
-          <a:effectRef idx="2">
-            <a:schemeClr val="accent1"/>
-          </a:effectRef>
-          <a:fontRef idx="minor">
-            <a:schemeClr val="lt1"/>
-          </a:fontRef>
-        </p:style>
-        <p:txBody>
-          <a:bodyPr rtlCol="0" anchor="ctr"/>
-          <a:lstStyle/>
-          <a:p>
-            <a:pPr algn="ctr"/>
-          </a:p>
-        </p:txBody>
-      </p:sp>
-      <p:sp>
-        <p:nvSpPr>
-          <p:cNvPr id="21" name="TextBox 20"/>
-          <p:cNvSpPr txBox="1"/>
-          <p:nvPr/>
-        </p:nvSpPr>
-        <p:spPr>
-          <a:xfrm>
-            <a:off x="731520" y="3986784"/>
-            <a:ext cx="548640" cy="457200"/>
-          </a:xfrm>
-          <a:prstGeom prst="rect">
-            <a:avLst/>
-          </a:prstGeom>
-          <a:noFill/>
-        </p:spPr>
-        <p:txBody>
-          <a:bodyPr wrap="square">
-            <a:spAutoFit/>
-          </a:bodyPr>
-          <a:lstStyle/>
-          <a:p>
-            <a:pPr algn="l">
-              <a:lnSpc>
-                <a:spcPct val="100000"/>
-              </a:lnSpc>
-            </a:pPr>
-            <a:r>
-              <a:rPr sz="2800" b="0">
-                <a:solidFill>
-                  <a:srgbClr val="E145FF"/>
-                </a:solidFill>
-                <a:latin typeface="Bebas Neue"/>
-              </a:rPr>
-              <a:t>3</a:t>
-            </a:r>
-          </a:p>
-        </p:txBody>
-      </p:sp>
-      <p:sp>
-        <p:nvSpPr>
-          <p:cNvPr id="22" name="TextBox 21"/>
-          <p:cNvSpPr txBox="1"/>
-          <p:nvPr/>
-        </p:nvSpPr>
-        <p:spPr>
-          <a:xfrm>
-            <a:off x="1371600" y="4032504"/>
-            <a:ext cx="2377440" cy="457200"/>
-          </a:xfrm>
-          <a:prstGeom prst="rect">
-            <a:avLst/>
-          </a:prstGeom>
-          <a:noFill/>
-        </p:spPr>
-        <p:txBody>
-          <a:bodyPr wrap="square">
-            <a:spAutoFit/>
-          </a:bodyPr>
-          <a:lstStyle/>
-          <a:p>
-            <a:pPr algn="l">
-              <a:lnSpc>
-                <a:spcPct val="115000"/>
-              </a:lnSpc>
-            </a:pPr>
-            <a:r>
-              <a:rPr sz="1500" b="1">
-                <a:solidFill>
-                  <a:srgbClr val="ECE7F7"/>
-                </a:solidFill>
-                <a:latin typeface="Inter"/>
-              </a:rPr>
-              <a:t>Jogo e conta</a:t>
-            </a:r>
-          </a:p>
-        </p:txBody>
-      </p:sp>
-      <p:sp>
-        <p:nvSpPr>
-          <p:cNvPr id="23" name="TextBox 22"/>
-          <p:cNvSpPr txBox="1"/>
-          <p:nvPr/>
-        </p:nvSpPr>
-        <p:spPr>
-          <a:xfrm>
-            <a:off x="3840480" y="4032504"/>
-            <a:ext cx="5852160" cy="457200"/>
-          </a:xfrm>
-          <a:prstGeom prst="rect">
-            <a:avLst/>
-          </a:prstGeom>
-          <a:noFill/>
-        </p:spPr>
-        <p:txBody>
-          <a:bodyPr wrap="square">
-            <a:spAutoFit/>
-          </a:bodyPr>
-          <a:lstStyle/>
-          <a:p>
-            <a:pPr algn="l">
-              <a:lnSpc>
-                <a:spcPct val="115000"/>
-              </a:lnSpc>
-            </a:pPr>
-            <a:r>
-              <a:rPr sz="1300" b="0">
-                <a:solidFill>
-                  <a:srgbClr val="9A90B8"/>
-                </a:solidFill>
-                <a:latin typeface="Inter"/>
-              </a:rPr>
-              <a:t>lançador do agregador, login e cadastro contra o backend da GirosBet</a:t>
-            </a:r>
-          </a:p>
-        </p:txBody>
-      </p:sp>
-      <p:sp>
-        <p:nvSpPr>
-          <p:cNvPr id="24" name="TextBox 23"/>
-          <p:cNvSpPr txBox="1"/>
-          <p:nvPr/>
-        </p:nvSpPr>
-        <p:spPr>
-          <a:xfrm>
-            <a:off x="9875520" y="4032504"/>
-            <a:ext cx="1737360" cy="457200"/>
-          </a:xfrm>
-          <a:prstGeom prst="rect">
-            <a:avLst/>
-          </a:prstGeom>
-          <a:noFill/>
-        </p:spPr>
-        <p:txBody>
-          <a:bodyPr wrap="square">
-            <a:spAutoFit/>
-          </a:bodyPr>
-          <a:lstStyle/>
-          <a:p>
-            <a:pPr algn="r">
-              <a:lnSpc>
-                <a:spcPct val="115000"/>
-              </a:lnSpc>
-            </a:pPr>
-            <a:r>
-              <a:rPr sz="1200" b="0">
-                <a:solidFill>
-                  <a:srgbClr val="ECE7F7"/>
-                </a:solidFill>
-                <a:latin typeface="Inter"/>
-              </a:rPr>
-              <a:t>[prazo]</a:t>
-            </a:r>
-          </a:p>
-        </p:txBody>
-      </p:sp>
-      <p:sp>
-        <p:nvSpPr>
-          <p:cNvPr id="25" name="Rectangle 24"/>
-          <p:cNvSpPr/>
-          <p:nvPr/>
-        </p:nvSpPr>
-        <p:spPr>
-          <a:xfrm>
-            <a:off x="731520" y="4553712"/>
-            <a:ext cx="10881360" cy="12700"/>
-          </a:xfrm>
-          <a:prstGeom prst="rect">
-            <a:avLst/>
-          </a:prstGeom>
-          <a:solidFill>
-            <a:srgbClr val="2A1547"/>
-          </a:solidFill>
-          <a:ln>
-            <a:noFill/>
-          </a:ln>
-        </p:spPr>
-        <p:style>
-          <a:lnRef idx="1">
-            <a:schemeClr val="accent1"/>
-          </a:lnRef>
-          <a:fillRef idx="3">
-            <a:schemeClr val="accent1"/>
-          </a:fillRef>
-          <a:effectRef idx="2">
-            <a:schemeClr val="accent1"/>
-          </a:effectRef>
-          <a:fontRef idx="minor">
-            <a:schemeClr val="lt1"/>
-          </a:fontRef>
-        </p:style>
-        <p:txBody>
-          <a:bodyPr rtlCol="0" anchor="ctr"/>
-          <a:lstStyle/>
-          <a:p>
-            <a:pPr algn="ctr"/>
-          </a:p>
-        </p:txBody>
-      </p:sp>
-      <p:sp>
-        <p:nvSpPr>
-          <p:cNvPr id="26" name="TextBox 25"/>
-          <p:cNvSpPr txBox="1"/>
-          <p:nvPr/>
-        </p:nvSpPr>
-        <p:spPr>
-          <a:xfrm>
-            <a:off x="731520" y="4645152"/>
-            <a:ext cx="548640" cy="457200"/>
-          </a:xfrm>
-          <a:prstGeom prst="rect">
-            <a:avLst/>
-          </a:prstGeom>
-          <a:noFill/>
-        </p:spPr>
-        <p:txBody>
-          <a:bodyPr wrap="square">
-            <a:spAutoFit/>
-          </a:bodyPr>
-          <a:lstStyle/>
-          <a:p>
-            <a:pPr algn="l">
-              <a:lnSpc>
-                <a:spcPct val="100000"/>
-              </a:lnSpc>
-            </a:pPr>
-            <a:r>
-              <a:rPr sz="2800" b="0">
-                <a:solidFill>
-                  <a:srgbClr val="E145FF"/>
-                </a:solidFill>
-                <a:latin typeface="Bebas Neue"/>
-              </a:rPr>
-              <a:t>4</a:t>
-            </a:r>
-          </a:p>
-        </p:txBody>
-      </p:sp>
-      <p:sp>
-        <p:nvSpPr>
-          <p:cNvPr id="27" name="TextBox 26"/>
-          <p:cNvSpPr txBox="1"/>
-          <p:nvPr/>
-        </p:nvSpPr>
-        <p:spPr>
-          <a:xfrm>
-            <a:off x="1371600" y="4690872"/>
-            <a:ext cx="2377440" cy="457200"/>
-          </a:xfrm>
-          <a:prstGeom prst="rect">
-            <a:avLst/>
-          </a:prstGeom>
-          <a:noFill/>
-        </p:spPr>
-        <p:txBody>
-          <a:bodyPr wrap="square">
-            <a:spAutoFit/>
-          </a:bodyPr>
-          <a:lstStyle/>
-          <a:p>
-            <a:pPr algn="l">
-              <a:lnSpc>
-                <a:spcPct val="115000"/>
-              </a:lnSpc>
-            </a:pPr>
-            <a:r>
-              <a:rPr sz="1500" b="1">
-                <a:solidFill>
-                  <a:srgbClr val="ECE7F7"/>
-                </a:solidFill>
-                <a:latin typeface="Inter"/>
-              </a:rPr>
-              <a:t>Área logada</a:t>
-            </a:r>
-          </a:p>
-        </p:txBody>
-      </p:sp>
-      <p:sp>
-        <p:nvSpPr>
-          <p:cNvPr id="28" name="TextBox 27"/>
-          <p:cNvSpPr txBox="1"/>
-          <p:nvPr/>
-        </p:nvSpPr>
-        <p:spPr>
-          <a:xfrm>
-            <a:off x="3840480" y="4690872"/>
-            <a:ext cx="5852160" cy="457200"/>
-          </a:xfrm>
-          <a:prstGeom prst="rect">
-            <a:avLst/>
-          </a:prstGeom>
-          <a:noFill/>
-        </p:spPr>
-        <p:txBody>
-          <a:bodyPr wrap="square">
-            <a:spAutoFit/>
-          </a:bodyPr>
-          <a:lstStyle/>
-          <a:p>
-            <a:pPr algn="l">
-              <a:lnSpc>
-                <a:spcPct val="115000"/>
-              </a:lnSpc>
-            </a:pPr>
-            <a:r>
-              <a:rPr sz="1300" b="0">
-                <a:solidFill>
-                  <a:srgbClr val="9A90B8"/>
-                </a:solidFill>
-                <a:latin typeface="Inter"/>
-              </a:rPr>
-              <a:t>camada de API nova: perfil, carteira, PIX, saque, histórico, KYC, bônus</a:t>
-            </a:r>
-          </a:p>
-        </p:txBody>
-      </p:sp>
-      <p:sp>
-        <p:nvSpPr>
-          <p:cNvPr id="29" name="TextBox 28"/>
-          <p:cNvSpPr txBox="1"/>
-          <p:nvPr/>
-        </p:nvSpPr>
-        <p:spPr>
-          <a:xfrm>
-            <a:off x="9875520" y="4690872"/>
-            <a:ext cx="1737360" cy="457200"/>
-          </a:xfrm>
-          <a:prstGeom prst="rect">
-            <a:avLst/>
-          </a:prstGeom>
-          <a:noFill/>
-        </p:spPr>
-        <p:txBody>
-          <a:bodyPr wrap="square">
-            <a:spAutoFit/>
-          </a:bodyPr>
-          <a:lstStyle/>
-          <a:p>
-            <a:pPr algn="r">
-              <a:lnSpc>
-                <a:spcPct val="115000"/>
-              </a:lnSpc>
-            </a:pPr>
-            <a:r>
-              <a:rPr sz="1200" b="0">
-                <a:solidFill>
-                  <a:srgbClr val="ECE7F7"/>
-                </a:solidFill>
-                <a:latin typeface="Inter"/>
-              </a:rPr>
-              <a:t>[prazo]</a:t>
-            </a:r>
-          </a:p>
-        </p:txBody>
-      </p:sp>
-      <p:sp>
-        <p:nvSpPr>
-          <p:cNvPr id="30" name="Rectangle 29"/>
-          <p:cNvSpPr/>
-          <p:nvPr/>
-        </p:nvSpPr>
-        <p:spPr>
-          <a:xfrm>
-            <a:off x="731520" y="5212080"/>
-            <a:ext cx="10881360" cy="12700"/>
-          </a:xfrm>
-          <a:prstGeom prst="rect">
-            <a:avLst/>
-          </a:prstGeom>
-          <a:solidFill>
-            <a:srgbClr val="2A1547"/>
-          </a:solidFill>
-          <a:ln>
-            <a:noFill/>
-          </a:ln>
-        </p:spPr>
-        <p:style>
-          <a:lnRef idx="1">
-            <a:schemeClr val="accent1"/>
-          </a:lnRef>
-          <a:fillRef idx="3">
-            <a:schemeClr val="accent1"/>
-          </a:fillRef>
-          <a:effectRef idx="2">
-            <a:schemeClr val="accent1"/>
-          </a:effectRef>
-          <a:fontRef idx="minor">
-            <a:schemeClr val="lt1"/>
-          </a:fontRef>
-        </p:style>
-        <p:txBody>
-          <a:bodyPr rtlCol="0" anchor="ctr"/>
-          <a:lstStyle/>
-          <a:p>
-            <a:pPr algn="ctr"/>
-          </a:p>
-        </p:txBody>
-      </p:sp>
-      <p:sp>
-        <p:nvSpPr>
-          <p:cNvPr id="31" name="TextBox 30"/>
-          <p:cNvSpPr txBox="1"/>
-          <p:nvPr/>
-        </p:nvSpPr>
-        <p:spPr>
-          <a:xfrm>
-            <a:off x="731520" y="5303520"/>
-            <a:ext cx="548640" cy="457200"/>
-          </a:xfrm>
-          <a:prstGeom prst="rect">
-            <a:avLst/>
-          </a:prstGeom>
-          <a:noFill/>
-        </p:spPr>
-        <p:txBody>
-          <a:bodyPr wrap="square">
-            <a:spAutoFit/>
-          </a:bodyPr>
-          <a:lstStyle/>
-          <a:p>
-            <a:pPr algn="l">
-              <a:lnSpc>
-                <a:spcPct val="100000"/>
-              </a:lnSpc>
-            </a:pPr>
-            <a:r>
-              <a:rPr sz="2800" b="0">
-                <a:solidFill>
-                  <a:srgbClr val="E145FF"/>
-                </a:solidFill>
-                <a:latin typeface="Bebas Neue"/>
-              </a:rPr>
-              <a:t>5</a:t>
-            </a:r>
-          </a:p>
-        </p:txBody>
-      </p:sp>
-      <p:sp>
-        <p:nvSpPr>
-          <p:cNvPr id="32" name="TextBox 31"/>
-          <p:cNvSpPr txBox="1"/>
-          <p:nvPr/>
-        </p:nvSpPr>
-        <p:spPr>
-          <a:xfrm>
-            <a:off x="1371600" y="5349240"/>
-            <a:ext cx="2377440" cy="457200"/>
-          </a:xfrm>
-          <a:prstGeom prst="rect">
-            <a:avLst/>
-          </a:prstGeom>
-          <a:noFill/>
-        </p:spPr>
-        <p:txBody>
-          <a:bodyPr wrap="square">
-            <a:spAutoFit/>
-          </a:bodyPr>
-          <a:lstStyle/>
-          <a:p>
-            <a:pPr algn="l">
-              <a:lnSpc>
-                <a:spcPct val="115000"/>
-              </a:lnSpc>
-            </a:pPr>
-            <a:r>
-              <a:rPr sz="1500" b="1">
-                <a:solidFill>
-                  <a:srgbClr val="ECE7F7"/>
-                </a:solidFill>
-                <a:latin typeface="Inter"/>
-              </a:rPr>
-              <a:t>Go-live</a:t>
-            </a:r>
-          </a:p>
-        </p:txBody>
-      </p:sp>
-      <p:sp>
-        <p:nvSpPr>
-          <p:cNvPr id="33" name="TextBox 32"/>
-          <p:cNvSpPr txBox="1"/>
-          <p:nvPr/>
-        </p:nvSpPr>
-        <p:spPr>
-          <a:xfrm>
-            <a:off x="3840480" y="5349240"/>
-            <a:ext cx="5852160" cy="457200"/>
-          </a:xfrm>
-          <a:prstGeom prst="rect">
-            <a:avLst/>
-          </a:prstGeom>
-          <a:noFill/>
-        </p:spPr>
-        <p:txBody>
-          <a:bodyPr wrap="square">
-            <a:spAutoFit/>
-          </a:bodyPr>
-          <a:lstStyle/>
-          <a:p>
-            <a:pPr algn="l">
-              <a:lnSpc>
-                <a:spcPct val="115000"/>
-              </a:lnSpc>
-            </a:pPr>
-            <a:r>
-              <a:rPr sz="1300" b="0">
-                <a:solidFill>
-                  <a:srgbClr val="9A90B8"/>
-                </a:solidFill>
-                <a:latin typeface="Inter"/>
-              </a:rPr>
-              <a:t>SEO, analytics, textos legais, monitoramento, cutover de domínio</a:t>
-            </a:r>
-          </a:p>
-        </p:txBody>
-      </p:sp>
-      <p:sp>
-        <p:nvSpPr>
-          <p:cNvPr id="34" name="TextBox 33"/>
-          <p:cNvSpPr txBox="1"/>
-          <p:nvPr/>
-        </p:nvSpPr>
-        <p:spPr>
-          <a:xfrm>
-            <a:off x="9875520" y="5349240"/>
-            <a:ext cx="1737360" cy="457200"/>
-          </a:xfrm>
-          <a:prstGeom prst="rect">
-            <a:avLst/>
-          </a:prstGeom>
-          <a:noFill/>
-        </p:spPr>
-        <p:txBody>
-          <a:bodyPr wrap="square">
-            <a:spAutoFit/>
-          </a:bodyPr>
-          <a:lstStyle/>
-          <a:p>
-            <a:pPr algn="r">
-              <a:lnSpc>
-                <a:spcPct val="115000"/>
-              </a:lnSpc>
-            </a:pPr>
-            <a:r>
-              <a:rPr sz="1200" b="0">
-                <a:solidFill>
-                  <a:srgbClr val="ECE7F7"/>
-                </a:solidFill>
-                <a:latin typeface="Inter"/>
-              </a:rPr>
-              <a:t>[prazo]</a:t>
-            </a:r>
-          </a:p>
-        </p:txBody>
-      </p:sp>
-      <p:sp>
-        <p:nvSpPr>
-          <p:cNvPr id="35" name="Rectangle 34"/>
-          <p:cNvSpPr/>
-          <p:nvPr/>
-        </p:nvSpPr>
-        <p:spPr>
-          <a:xfrm>
-            <a:off x="731520" y="5870448"/>
-            <a:ext cx="10881360" cy="12700"/>
-          </a:xfrm>
-          <a:prstGeom prst="rect">
-            <a:avLst/>
-          </a:prstGeom>
-          <a:solidFill>
-            <a:srgbClr val="2A1547"/>
-          </a:solidFill>
-          <a:ln>
-            <a:noFill/>
-          </a:ln>
-        </p:spPr>
-        <p:style>
-          <a:lnRef idx="1">
-            <a:schemeClr val="accent1"/>
-          </a:lnRef>
-          <a:fillRef idx="3">
-            <a:schemeClr val="accent1"/>
-          </a:fillRef>
-          <a:effectRef idx="2">
-            <a:schemeClr val="accent1"/>
-          </a:effectRef>
-          <a:fontRef idx="minor">
-            <a:schemeClr val="lt1"/>
-          </a:fontRef>
-        </p:style>
-        <p:txBody>
-          <a:bodyPr rtlCol="0" anchor="ctr"/>
-          <a:lstStyle/>
-          <a:p>
-            <a:pPr algn="ctr"/>
-          </a:p>
-        </p:txBody>
-      </p:sp>
-      <p:sp>
-        <p:nvSpPr>
-          <p:cNvPr id="36" name="TextBox 35"/>
-          <p:cNvSpPr txBox="1"/>
-          <p:nvPr/>
-        </p:nvSpPr>
-        <p:spPr>
-          <a:xfrm>
-            <a:off x="731520" y="5989320"/>
-            <a:ext cx="10972800" cy="365760"/>
-          </a:xfrm>
-          <a:prstGeom prst="rect">
-            <a:avLst/>
-          </a:prstGeom>
-          <a:noFill/>
-        </p:spPr>
-        <p:txBody>
-          <a:bodyPr wrap="square">
-            <a:spAutoFit/>
-          </a:bodyPr>
-          <a:lstStyle/>
-          <a:p>
-            <a:pPr algn="l">
-              <a:lnSpc>
-                <a:spcPct val="115000"/>
-              </a:lnSpc>
-            </a:pPr>
-            <a:r>
-              <a:rPr sz="1100" b="0">
-                <a:solidFill>
-                  <a:srgbClr val="9A90B8"/>
-                </a:solidFill>
-                <a:latin typeface="Inter"/>
-              </a:rPr>
-              <a:t>Fora de escopo: sportsbook novo, app nativo, programa de afiliados, idiomas além de pt-BR.</a:t>
+              <a:t>Diálogo único de idade + cookies; rodapé regulatório completo.</a:t>
             </a:r>
           </a:p>
         </p:txBody>
@@ -7002,7 +6888,7 @@
                 </a:solidFill>
                 <a:latin typeface="Inter"/>
               </a:rPr>
-              <a:t>PARA COMEÇAR</a:t>
+              <a:t>ESCOPO</a:t>
             </a:r>
           </a:p>
         </p:txBody>
@@ -7041,7 +6927,7 @@
                 </a:solidFill>
                 <a:latin typeface="Bebas Neue"/>
               </a:rPr>
-              <a:t>O que precisamos da GirosBet</a:t>
+              <a:t>Seis fases</a:t>
             </a:r>
           </a:p>
         </p:txBody>
@@ -7055,128 +6941,1226 @@
         <p:spPr>
           <a:xfrm>
             <a:off x="731520" y="2011680"/>
-            <a:ext cx="10515600" cy="4114800"/>
-          </a:xfrm>
-          <a:prstGeom prst="rect">
-            <a:avLst/>
-          </a:prstGeom>
-          <a:noFill/>
-        </p:spPr>
-        <p:txBody>
-          <a:bodyPr wrap="square">
-            <a:spAutoFit/>
-          </a:bodyPr>
-          <a:lstStyle/>
-          <a:p>
-            <a:pPr algn="l">
-              <a:lnSpc>
-                <a:spcPct val="145000"/>
-              </a:lnSpc>
-            </a:pPr>
-            <a:r>
-              <a:rPr sz="1500" b="0">
+            <a:ext cx="548640" cy="457200"/>
+          </a:xfrm>
+          <a:prstGeom prst="rect">
+            <a:avLst/>
+          </a:prstGeom>
+          <a:noFill/>
+        </p:spPr>
+        <p:txBody>
+          <a:bodyPr wrap="square">
+            <a:spAutoFit/>
+          </a:bodyPr>
+          <a:lstStyle/>
+          <a:p>
+            <a:pPr algn="l">
+              <a:lnSpc>
+                <a:spcPct val="100000"/>
+              </a:lnSpc>
+            </a:pPr>
+            <a:r>
+              <a:rPr sz="2800" b="0">
+                <a:solidFill>
+                  <a:srgbClr val="E145FF"/>
+                </a:solidFill>
+                <a:latin typeface="Bebas Neue"/>
+              </a:rPr>
+              <a:t>0</a:t>
+            </a:r>
+          </a:p>
+        </p:txBody>
+      </p:sp>
+      <p:sp>
+        <p:nvSpPr>
+          <p:cNvPr id="7" name="TextBox 6"/>
+          <p:cNvSpPr txBox="1"/>
+          <p:nvPr/>
+        </p:nvSpPr>
+        <p:spPr>
+          <a:xfrm>
+            <a:off x="1371600" y="2057400"/>
+            <a:ext cx="2377440" cy="457200"/>
+          </a:xfrm>
+          <a:prstGeom prst="rect">
+            <a:avLst/>
+          </a:prstGeom>
+          <a:noFill/>
+        </p:spPr>
+        <p:txBody>
+          <a:bodyPr wrap="square">
+            <a:spAutoFit/>
+          </a:bodyPr>
+          <a:lstStyle/>
+          <a:p>
+            <a:pPr algn="l">
+              <a:lnSpc>
+                <a:spcPct val="115000"/>
+              </a:lnSpc>
+            </a:pPr>
+            <a:r>
+              <a:rPr sz="1500" b="1">
                 <a:solidFill>
                   <a:srgbClr val="ECE7F7"/>
                 </a:solidFill>
                 <a:latin typeface="Inter"/>
               </a:rPr>
-              <a:t>1.  Kit de marca: logo em vetor, paleta oficial (o roxo principal é #901bf7 ou #e145ff?), fontes, mascote.</a:t>
-            </a:r>
-          </a:p>
-          <a:p>
-            <a:pPr algn="l">
-              <a:lnSpc>
-                <a:spcPct val="145000"/>
-              </a:lnSpc>
-            </a:pPr>
-            <a:r>
-              <a:rPr sz="1500" b="0">
+              <a:t>Fundação</a:t>
+            </a:r>
+          </a:p>
+        </p:txBody>
+      </p:sp>
+      <p:sp>
+        <p:nvSpPr>
+          <p:cNvPr id="8" name="TextBox 7"/>
+          <p:cNvSpPr txBox="1"/>
+          <p:nvPr/>
+        </p:nvSpPr>
+        <p:spPr>
+          <a:xfrm>
+            <a:off x="3840480" y="2057400"/>
+            <a:ext cx="5852160" cy="457200"/>
+          </a:xfrm>
+          <a:prstGeom prst="rect">
+            <a:avLst/>
+          </a:prstGeom>
+          <a:noFill/>
+        </p:spPr>
+        <p:txBody>
+          <a:bodyPr wrap="square">
+            <a:spAutoFit/>
+          </a:bodyPr>
+          <a:lstStyle/>
+          <a:p>
+            <a:pPr algn="l">
+              <a:lnSpc>
+                <a:spcPct val="115000"/>
+              </a:lnSpc>
+            </a:pPr>
+            <a:r>
+              <a:rPr sz="1300" b="0">
+                <a:solidFill>
+                  <a:srgbClr val="9A90B8"/>
+                </a:solidFill>
+                <a:latin typeface="Inter"/>
+              </a:rPr>
+              <a:t>tooling, white-label, BetAki como marca 1 sem regressão</a:t>
+            </a:r>
+          </a:p>
+        </p:txBody>
+      </p:sp>
+      <p:sp>
+        <p:nvSpPr>
+          <p:cNvPr id="9" name="TextBox 8"/>
+          <p:cNvSpPr txBox="1"/>
+          <p:nvPr/>
+        </p:nvSpPr>
+        <p:spPr>
+          <a:xfrm>
+            <a:off x="9875520" y="2057400"/>
+            <a:ext cx="1737360" cy="457200"/>
+          </a:xfrm>
+          <a:prstGeom prst="rect">
+            <a:avLst/>
+          </a:prstGeom>
+          <a:noFill/>
+        </p:spPr>
+        <p:txBody>
+          <a:bodyPr wrap="square">
+            <a:spAutoFit/>
+          </a:bodyPr>
+          <a:lstStyle/>
+          <a:p>
+            <a:pPr algn="r">
+              <a:lnSpc>
+                <a:spcPct val="115000"/>
+              </a:lnSpc>
+            </a:pPr>
+            <a:r>
+              <a:rPr sz="1200" b="0">
                 <a:solidFill>
                   <a:srgbClr val="ECE7F7"/>
                 </a:solidFill>
                 <a:latin typeface="Inter"/>
               </a:rPr>
-              <a:t>2.  Documentação e sandbox do backend e do agregador: auth, carteira, PIX, catálogo, lançamento, webhooks.</a:t>
-            </a:r>
-          </a:p>
-          <a:p>
-            <a:pPr algn="l">
-              <a:lnSpc>
-                <a:spcPct val="145000"/>
-              </a:lnSpc>
-            </a:pPr>
-            <a:r>
-              <a:rPr sz="1500" b="0">
+              <a:t>feito</a:t>
+            </a:r>
+          </a:p>
+        </p:txBody>
+      </p:sp>
+      <p:sp>
+        <p:nvSpPr>
+          <p:cNvPr id="10" name="Rectangle 9"/>
+          <p:cNvSpPr/>
+          <p:nvPr/>
+        </p:nvSpPr>
+        <p:spPr>
+          <a:xfrm>
+            <a:off x="731520" y="2578608"/>
+            <a:ext cx="10881360" cy="12700"/>
+          </a:xfrm>
+          <a:prstGeom prst="rect">
+            <a:avLst/>
+          </a:prstGeom>
+          <a:solidFill>
+            <a:srgbClr val="2A1547"/>
+          </a:solidFill>
+          <a:ln>
+            <a:noFill/>
+          </a:ln>
+        </p:spPr>
+        <p:style>
+          <a:lnRef idx="1">
+            <a:schemeClr val="accent1"/>
+          </a:lnRef>
+          <a:fillRef idx="3">
+            <a:schemeClr val="accent1"/>
+          </a:fillRef>
+          <a:effectRef idx="2">
+            <a:schemeClr val="accent1"/>
+          </a:effectRef>
+          <a:fontRef idx="minor">
+            <a:schemeClr val="lt1"/>
+          </a:fontRef>
+        </p:style>
+        <p:txBody>
+          <a:bodyPr rtlCol="0" anchor="ctr"/>
+          <a:lstStyle/>
+          <a:p>
+            <a:pPr algn="ctr"/>
+          </a:p>
+        </p:txBody>
+      </p:sp>
+      <p:sp>
+        <p:nvSpPr>
+          <p:cNvPr id="11" name="TextBox 10"/>
+          <p:cNvSpPr txBox="1"/>
+          <p:nvPr/>
+        </p:nvSpPr>
+        <p:spPr>
+          <a:xfrm>
+            <a:off x="731520" y="2670048"/>
+            <a:ext cx="548640" cy="457200"/>
+          </a:xfrm>
+          <a:prstGeom prst="rect">
+            <a:avLst/>
+          </a:prstGeom>
+          <a:noFill/>
+        </p:spPr>
+        <p:txBody>
+          <a:bodyPr wrap="square">
+            <a:spAutoFit/>
+          </a:bodyPr>
+          <a:lstStyle/>
+          <a:p>
+            <a:pPr algn="l">
+              <a:lnSpc>
+                <a:spcPct val="100000"/>
+              </a:lnSpc>
+            </a:pPr>
+            <a:r>
+              <a:rPr sz="2800" b="0">
+                <a:solidFill>
+                  <a:srgbClr val="E145FF"/>
+                </a:solidFill>
+                <a:latin typeface="Bebas Neue"/>
+              </a:rPr>
+              <a:t>1</a:t>
+            </a:r>
+          </a:p>
+        </p:txBody>
+      </p:sp>
+      <p:sp>
+        <p:nvSpPr>
+          <p:cNvPr id="12" name="TextBox 11"/>
+          <p:cNvSpPr txBox="1"/>
+          <p:nvPr/>
+        </p:nvSpPr>
+        <p:spPr>
+          <a:xfrm>
+            <a:off x="1371600" y="2715768"/>
+            <a:ext cx="2377440" cy="457200"/>
+          </a:xfrm>
+          <a:prstGeom prst="rect">
+            <a:avLst/>
+          </a:prstGeom>
+          <a:noFill/>
+        </p:spPr>
+        <p:txBody>
+          <a:bodyPr wrap="square">
+            <a:spAutoFit/>
+          </a:bodyPr>
+          <a:lstStyle/>
+          <a:p>
+            <a:pPr algn="l">
+              <a:lnSpc>
+                <a:spcPct val="115000"/>
+              </a:lnSpc>
+            </a:pPr>
+            <a:r>
+              <a:rPr sz="1500" b="1">
                 <a:solidFill>
                   <a:srgbClr val="ECE7F7"/>
                 </a:solidFill>
                 <a:latin typeface="Inter"/>
               </a:rPr>
-              <a:t>3.  Vendor de sportsbook e de KYC, com credenciais de teste.</a:t>
-            </a:r>
-          </a:p>
-          <a:p>
-            <a:pPr algn="l">
-              <a:lnSpc>
-                <a:spcPct val="145000"/>
-              </a:lnSpc>
-            </a:pPr>
-            <a:r>
-              <a:rPr sz="1500" b="0">
+              <a:t>Marca GirosBet</a:t>
+            </a:r>
+          </a:p>
+        </p:txBody>
+      </p:sp>
+      <p:sp>
+        <p:nvSpPr>
+          <p:cNvPr id="13" name="TextBox 12"/>
+          <p:cNvSpPr txBox="1"/>
+          <p:nvPr/>
+        </p:nvSpPr>
+        <p:spPr>
+          <a:xfrm>
+            <a:off x="3840480" y="2715768"/>
+            <a:ext cx="5852160" cy="457200"/>
+          </a:xfrm>
+          <a:prstGeom prst="rect">
+            <a:avLst/>
+          </a:prstGeom>
+          <a:noFill/>
+        </p:spPr>
+        <p:txBody>
+          <a:bodyPr wrap="square">
+            <a:spAutoFit/>
+          </a:bodyPr>
+          <a:lstStyle/>
+          <a:p>
+            <a:pPr algn="l">
+              <a:lnSpc>
+                <a:spcPct val="115000"/>
+              </a:lnSpc>
+            </a:pPr>
+            <a:r>
+              <a:rPr sz="1300" b="0">
+                <a:solidFill>
+                  <a:srgbClr val="9A90B8"/>
+                </a:solidFill>
+                <a:latin typeface="Inter"/>
+              </a:rPr>
+              <a:t>pacote de marca, home, lobbies, busca, header, sidebar, footer</a:t>
+            </a:r>
+          </a:p>
+        </p:txBody>
+      </p:sp>
+      <p:sp>
+        <p:nvSpPr>
+          <p:cNvPr id="14" name="TextBox 13"/>
+          <p:cNvSpPr txBox="1"/>
+          <p:nvPr/>
+        </p:nvSpPr>
+        <p:spPr>
+          <a:xfrm>
+            <a:off x="9875520" y="2715768"/>
+            <a:ext cx="1737360" cy="457200"/>
+          </a:xfrm>
+          <a:prstGeom prst="rect">
+            <a:avLst/>
+          </a:prstGeom>
+          <a:noFill/>
+        </p:spPr>
+        <p:txBody>
+          <a:bodyPr wrap="square">
+            <a:spAutoFit/>
+          </a:bodyPr>
+          <a:lstStyle/>
+          <a:p>
+            <a:pPr algn="r">
+              <a:lnSpc>
+                <a:spcPct val="115000"/>
+              </a:lnSpc>
+            </a:pPr>
+            <a:r>
+              <a:rPr sz="1200" b="0">
                 <a:solidFill>
                   <a:srgbClr val="ECE7F7"/>
                 </a:solidFill>
                 <a:latin typeface="Inter"/>
               </a:rPr>
-              <a:t>4.  Textos legais, licenciamento e selos do rodapé.</a:t>
-            </a:r>
-          </a:p>
-          <a:p>
-            <a:pPr algn="l">
-              <a:lnSpc>
-                <a:spcPct val="145000"/>
-              </a:lnSpc>
-            </a:pPr>
-            <a:r>
-              <a:rPr sz="1500" b="0">
+              <a:t>em andamento</a:t>
+            </a:r>
+          </a:p>
+        </p:txBody>
+      </p:sp>
+      <p:sp>
+        <p:nvSpPr>
+          <p:cNvPr id="15" name="Rectangle 14"/>
+          <p:cNvSpPr/>
+          <p:nvPr/>
+        </p:nvSpPr>
+        <p:spPr>
+          <a:xfrm>
+            <a:off x="731520" y="3236976"/>
+            <a:ext cx="10881360" cy="12700"/>
+          </a:xfrm>
+          <a:prstGeom prst="rect">
+            <a:avLst/>
+          </a:prstGeom>
+          <a:solidFill>
+            <a:srgbClr val="2A1547"/>
+          </a:solidFill>
+          <a:ln>
+            <a:noFill/>
+          </a:ln>
+        </p:spPr>
+        <p:style>
+          <a:lnRef idx="1">
+            <a:schemeClr val="accent1"/>
+          </a:lnRef>
+          <a:fillRef idx="3">
+            <a:schemeClr val="accent1"/>
+          </a:fillRef>
+          <a:effectRef idx="2">
+            <a:schemeClr val="accent1"/>
+          </a:effectRef>
+          <a:fontRef idx="minor">
+            <a:schemeClr val="lt1"/>
+          </a:fontRef>
+        </p:style>
+        <p:txBody>
+          <a:bodyPr rtlCol="0" anchor="ctr"/>
+          <a:lstStyle/>
+          <a:p>
+            <a:pPr algn="ctr"/>
+          </a:p>
+        </p:txBody>
+      </p:sp>
+      <p:sp>
+        <p:nvSpPr>
+          <p:cNvPr id="16" name="TextBox 15"/>
+          <p:cNvSpPr txBox="1"/>
+          <p:nvPr/>
+        </p:nvSpPr>
+        <p:spPr>
+          <a:xfrm>
+            <a:off x="731520" y="3328416"/>
+            <a:ext cx="548640" cy="457200"/>
+          </a:xfrm>
+          <a:prstGeom prst="rect">
+            <a:avLst/>
+          </a:prstGeom>
+          <a:noFill/>
+        </p:spPr>
+        <p:txBody>
+          <a:bodyPr wrap="square">
+            <a:spAutoFit/>
+          </a:bodyPr>
+          <a:lstStyle/>
+          <a:p>
+            <a:pPr algn="l">
+              <a:lnSpc>
+                <a:spcPct val="100000"/>
+              </a:lnSpc>
+            </a:pPr>
+            <a:r>
+              <a:rPr sz="2800" b="0">
+                <a:solidFill>
+                  <a:srgbClr val="E145FF"/>
+                </a:solidFill>
+                <a:latin typeface="Bebas Neue"/>
+              </a:rPr>
+              <a:t>2</a:t>
+            </a:r>
+          </a:p>
+        </p:txBody>
+      </p:sp>
+      <p:sp>
+        <p:nvSpPr>
+          <p:cNvPr id="17" name="TextBox 16"/>
+          <p:cNvSpPr txBox="1"/>
+          <p:nvPr/>
+        </p:nvSpPr>
+        <p:spPr>
+          <a:xfrm>
+            <a:off x="1371600" y="3374136"/>
+            <a:ext cx="2377440" cy="457200"/>
+          </a:xfrm>
+          <a:prstGeom prst="rect">
+            <a:avLst/>
+          </a:prstGeom>
+          <a:noFill/>
+        </p:spPr>
+        <p:txBody>
+          <a:bodyPr wrap="square">
+            <a:spAutoFit/>
+          </a:bodyPr>
+          <a:lstStyle/>
+          <a:p>
+            <a:pPr algn="l">
+              <a:lnSpc>
+                <a:spcPct val="115000"/>
+              </a:lnSpc>
+            </a:pPr>
+            <a:r>
+              <a:rPr sz="1500" b="1">
                 <a:solidFill>
                   <a:srgbClr val="ECE7F7"/>
                 </a:solidFill>
                 <a:latin typeface="Inter"/>
               </a:rPr>
-              <a:t>5.  Contas de GTM/GA, pixel de afiliados, chat.</a:t>
-            </a:r>
-          </a:p>
-          <a:p>
-            <a:pPr algn="l">
-              <a:lnSpc>
-                <a:spcPct val="145000"/>
-              </a:lnSpc>
-            </a:pPr>
-            <a:r>
-              <a:rPr sz="1500" b="0">
+              <a:t>CMS GirosBet</a:t>
+            </a:r>
+          </a:p>
+        </p:txBody>
+      </p:sp>
+      <p:sp>
+        <p:nvSpPr>
+          <p:cNvPr id="18" name="TextBox 17"/>
+          <p:cNvSpPr txBox="1"/>
+          <p:nvPr/>
+        </p:nvSpPr>
+        <p:spPr>
+          <a:xfrm>
+            <a:off x="3840480" y="3374136"/>
+            <a:ext cx="5852160" cy="457200"/>
+          </a:xfrm>
+          <a:prstGeom prst="rect">
+            <a:avLst/>
+          </a:prstGeom>
+          <a:noFill/>
+        </p:spPr>
+        <p:txBody>
+          <a:bodyPr wrap="square">
+            <a:spAutoFit/>
+          </a:bodyPr>
+          <a:lstStyle/>
+          <a:p>
+            <a:pPr algn="l">
+              <a:lnSpc>
+                <a:spcPct val="115000"/>
+              </a:lnSpc>
+            </a:pPr>
+            <a:r>
+              <a:rPr sz="1300" b="0">
+                <a:solidFill>
+                  <a:srgbClr val="9A90B8"/>
+                </a:solidFill>
+                <a:latin typeface="Inter"/>
+              </a:rPr>
+              <a:t>instância própria, importação de catálogo, menus, banners, carrosséis</a:t>
+            </a:r>
+          </a:p>
+        </p:txBody>
+      </p:sp>
+      <p:sp>
+        <p:nvSpPr>
+          <p:cNvPr id="19" name="TextBox 18"/>
+          <p:cNvSpPr txBox="1"/>
+          <p:nvPr/>
+        </p:nvSpPr>
+        <p:spPr>
+          <a:xfrm>
+            <a:off x="9875520" y="3374136"/>
+            <a:ext cx="1737360" cy="457200"/>
+          </a:xfrm>
+          <a:prstGeom prst="rect">
+            <a:avLst/>
+          </a:prstGeom>
+          <a:noFill/>
+        </p:spPr>
+        <p:txBody>
+          <a:bodyPr wrap="square">
+            <a:spAutoFit/>
+          </a:bodyPr>
+          <a:lstStyle/>
+          <a:p>
+            <a:pPr algn="r">
+              <a:lnSpc>
+                <a:spcPct val="115000"/>
+              </a:lnSpc>
+            </a:pPr>
+            <a:r>
+              <a:rPr sz="1200" b="0">
                 <a:solidFill>
                   <a:srgbClr val="ECE7F7"/>
                 </a:solidFill>
                 <a:latin typeface="Inter"/>
               </a:rPr>
-              <a:t>6.  Domínio e infra de deploy, ou definimos a nossa.</a:t>
-            </a:r>
-          </a:p>
-          <a:p>
-            <a:pPr algn="l">
-              <a:lnSpc>
-                <a:spcPct val="145000"/>
-              </a:lnSpc>
-            </a:pPr>
-            <a:r>
-              <a:rPr sz="1500" b="0">
+              <a:t>[prazo]</a:t>
+            </a:r>
+          </a:p>
+        </p:txBody>
+      </p:sp>
+      <p:sp>
+        <p:nvSpPr>
+          <p:cNvPr id="20" name="Rectangle 19"/>
+          <p:cNvSpPr/>
+          <p:nvPr/>
+        </p:nvSpPr>
+        <p:spPr>
+          <a:xfrm>
+            <a:off x="731520" y="3895344"/>
+            <a:ext cx="10881360" cy="12700"/>
+          </a:xfrm>
+          <a:prstGeom prst="rect">
+            <a:avLst/>
+          </a:prstGeom>
+          <a:solidFill>
+            <a:srgbClr val="2A1547"/>
+          </a:solidFill>
+          <a:ln>
+            <a:noFill/>
+          </a:ln>
+        </p:spPr>
+        <p:style>
+          <a:lnRef idx="1">
+            <a:schemeClr val="accent1"/>
+          </a:lnRef>
+          <a:fillRef idx="3">
+            <a:schemeClr val="accent1"/>
+          </a:fillRef>
+          <a:effectRef idx="2">
+            <a:schemeClr val="accent1"/>
+          </a:effectRef>
+          <a:fontRef idx="minor">
+            <a:schemeClr val="lt1"/>
+          </a:fontRef>
+        </p:style>
+        <p:txBody>
+          <a:bodyPr rtlCol="0" anchor="ctr"/>
+          <a:lstStyle/>
+          <a:p>
+            <a:pPr algn="ctr"/>
+          </a:p>
+        </p:txBody>
+      </p:sp>
+      <p:sp>
+        <p:nvSpPr>
+          <p:cNvPr id="21" name="TextBox 20"/>
+          <p:cNvSpPr txBox="1"/>
+          <p:nvPr/>
+        </p:nvSpPr>
+        <p:spPr>
+          <a:xfrm>
+            <a:off x="731520" y="3986784"/>
+            <a:ext cx="548640" cy="457200"/>
+          </a:xfrm>
+          <a:prstGeom prst="rect">
+            <a:avLst/>
+          </a:prstGeom>
+          <a:noFill/>
+        </p:spPr>
+        <p:txBody>
+          <a:bodyPr wrap="square">
+            <a:spAutoFit/>
+          </a:bodyPr>
+          <a:lstStyle/>
+          <a:p>
+            <a:pPr algn="l">
+              <a:lnSpc>
+                <a:spcPct val="100000"/>
+              </a:lnSpc>
+            </a:pPr>
+            <a:r>
+              <a:rPr sz="2800" b="0">
+                <a:solidFill>
+                  <a:srgbClr val="E145FF"/>
+                </a:solidFill>
+                <a:latin typeface="Bebas Neue"/>
+              </a:rPr>
+              <a:t>3</a:t>
+            </a:r>
+          </a:p>
+        </p:txBody>
+      </p:sp>
+      <p:sp>
+        <p:nvSpPr>
+          <p:cNvPr id="22" name="TextBox 21"/>
+          <p:cNvSpPr txBox="1"/>
+          <p:nvPr/>
+        </p:nvSpPr>
+        <p:spPr>
+          <a:xfrm>
+            <a:off x="1371600" y="4032504"/>
+            <a:ext cx="2377440" cy="457200"/>
+          </a:xfrm>
+          <a:prstGeom prst="rect">
+            <a:avLst/>
+          </a:prstGeom>
+          <a:noFill/>
+        </p:spPr>
+        <p:txBody>
+          <a:bodyPr wrap="square">
+            <a:spAutoFit/>
+          </a:bodyPr>
+          <a:lstStyle/>
+          <a:p>
+            <a:pPr algn="l">
+              <a:lnSpc>
+                <a:spcPct val="115000"/>
+              </a:lnSpc>
+            </a:pPr>
+            <a:r>
+              <a:rPr sz="1500" b="1">
                 <a:solidFill>
                   <a:srgbClr val="ECE7F7"/>
                 </a:solidFill>
                 <a:latin typeface="Inter"/>
               </a:rPr>
-              <a:t>7.  Uma pessoa de produto do lado da GirosBet para validar a área logada.</a:t>
+              <a:t>Jogo e conta</a:t>
+            </a:r>
+          </a:p>
+        </p:txBody>
+      </p:sp>
+      <p:sp>
+        <p:nvSpPr>
+          <p:cNvPr id="23" name="TextBox 22"/>
+          <p:cNvSpPr txBox="1"/>
+          <p:nvPr/>
+        </p:nvSpPr>
+        <p:spPr>
+          <a:xfrm>
+            <a:off x="3840480" y="4032504"/>
+            <a:ext cx="5852160" cy="457200"/>
+          </a:xfrm>
+          <a:prstGeom prst="rect">
+            <a:avLst/>
+          </a:prstGeom>
+          <a:noFill/>
+        </p:spPr>
+        <p:txBody>
+          <a:bodyPr wrap="square">
+            <a:spAutoFit/>
+          </a:bodyPr>
+          <a:lstStyle/>
+          <a:p>
+            <a:pPr algn="l">
+              <a:lnSpc>
+                <a:spcPct val="115000"/>
+              </a:lnSpc>
+            </a:pPr>
+            <a:r>
+              <a:rPr sz="1300" b="0">
+                <a:solidFill>
+                  <a:srgbClr val="9A90B8"/>
+                </a:solidFill>
+                <a:latin typeface="Inter"/>
+              </a:rPr>
+              <a:t>lançador do agregador, login e cadastro contra o backend da GirosBet</a:t>
+            </a:r>
+          </a:p>
+        </p:txBody>
+      </p:sp>
+      <p:sp>
+        <p:nvSpPr>
+          <p:cNvPr id="24" name="TextBox 23"/>
+          <p:cNvSpPr txBox="1"/>
+          <p:nvPr/>
+        </p:nvSpPr>
+        <p:spPr>
+          <a:xfrm>
+            <a:off x="9875520" y="4032504"/>
+            <a:ext cx="1737360" cy="457200"/>
+          </a:xfrm>
+          <a:prstGeom prst="rect">
+            <a:avLst/>
+          </a:prstGeom>
+          <a:noFill/>
+        </p:spPr>
+        <p:txBody>
+          <a:bodyPr wrap="square">
+            <a:spAutoFit/>
+          </a:bodyPr>
+          <a:lstStyle/>
+          <a:p>
+            <a:pPr algn="r">
+              <a:lnSpc>
+                <a:spcPct val="115000"/>
+              </a:lnSpc>
+            </a:pPr>
+            <a:r>
+              <a:rPr sz="1200" b="0">
+                <a:solidFill>
+                  <a:srgbClr val="ECE7F7"/>
+                </a:solidFill>
+                <a:latin typeface="Inter"/>
+              </a:rPr>
+              <a:t>[prazo]</a:t>
+            </a:r>
+          </a:p>
+        </p:txBody>
+      </p:sp>
+      <p:sp>
+        <p:nvSpPr>
+          <p:cNvPr id="25" name="Rectangle 24"/>
+          <p:cNvSpPr/>
+          <p:nvPr/>
+        </p:nvSpPr>
+        <p:spPr>
+          <a:xfrm>
+            <a:off x="731520" y="4553712"/>
+            <a:ext cx="10881360" cy="12700"/>
+          </a:xfrm>
+          <a:prstGeom prst="rect">
+            <a:avLst/>
+          </a:prstGeom>
+          <a:solidFill>
+            <a:srgbClr val="2A1547"/>
+          </a:solidFill>
+          <a:ln>
+            <a:noFill/>
+          </a:ln>
+        </p:spPr>
+        <p:style>
+          <a:lnRef idx="1">
+            <a:schemeClr val="accent1"/>
+          </a:lnRef>
+          <a:fillRef idx="3">
+            <a:schemeClr val="accent1"/>
+          </a:fillRef>
+          <a:effectRef idx="2">
+            <a:schemeClr val="accent1"/>
+          </a:effectRef>
+          <a:fontRef idx="minor">
+            <a:schemeClr val="lt1"/>
+          </a:fontRef>
+        </p:style>
+        <p:txBody>
+          <a:bodyPr rtlCol="0" anchor="ctr"/>
+          <a:lstStyle/>
+          <a:p>
+            <a:pPr algn="ctr"/>
+          </a:p>
+        </p:txBody>
+      </p:sp>
+      <p:sp>
+        <p:nvSpPr>
+          <p:cNvPr id="26" name="TextBox 25"/>
+          <p:cNvSpPr txBox="1"/>
+          <p:nvPr/>
+        </p:nvSpPr>
+        <p:spPr>
+          <a:xfrm>
+            <a:off x="731520" y="4645152"/>
+            <a:ext cx="548640" cy="457200"/>
+          </a:xfrm>
+          <a:prstGeom prst="rect">
+            <a:avLst/>
+          </a:prstGeom>
+          <a:noFill/>
+        </p:spPr>
+        <p:txBody>
+          <a:bodyPr wrap="square">
+            <a:spAutoFit/>
+          </a:bodyPr>
+          <a:lstStyle/>
+          <a:p>
+            <a:pPr algn="l">
+              <a:lnSpc>
+                <a:spcPct val="100000"/>
+              </a:lnSpc>
+            </a:pPr>
+            <a:r>
+              <a:rPr sz="2800" b="0">
+                <a:solidFill>
+                  <a:srgbClr val="E145FF"/>
+                </a:solidFill>
+                <a:latin typeface="Bebas Neue"/>
+              </a:rPr>
+              <a:t>4</a:t>
+            </a:r>
+          </a:p>
+        </p:txBody>
+      </p:sp>
+      <p:sp>
+        <p:nvSpPr>
+          <p:cNvPr id="27" name="TextBox 26"/>
+          <p:cNvSpPr txBox="1"/>
+          <p:nvPr/>
+        </p:nvSpPr>
+        <p:spPr>
+          <a:xfrm>
+            <a:off x="1371600" y="4690872"/>
+            <a:ext cx="2377440" cy="457200"/>
+          </a:xfrm>
+          <a:prstGeom prst="rect">
+            <a:avLst/>
+          </a:prstGeom>
+          <a:noFill/>
+        </p:spPr>
+        <p:txBody>
+          <a:bodyPr wrap="square">
+            <a:spAutoFit/>
+          </a:bodyPr>
+          <a:lstStyle/>
+          <a:p>
+            <a:pPr algn="l">
+              <a:lnSpc>
+                <a:spcPct val="115000"/>
+              </a:lnSpc>
+            </a:pPr>
+            <a:r>
+              <a:rPr sz="1500" b="1">
+                <a:solidFill>
+                  <a:srgbClr val="ECE7F7"/>
+                </a:solidFill>
+                <a:latin typeface="Inter"/>
+              </a:rPr>
+              <a:t>Área logada</a:t>
+            </a:r>
+          </a:p>
+        </p:txBody>
+      </p:sp>
+      <p:sp>
+        <p:nvSpPr>
+          <p:cNvPr id="28" name="TextBox 27"/>
+          <p:cNvSpPr txBox="1"/>
+          <p:nvPr/>
+        </p:nvSpPr>
+        <p:spPr>
+          <a:xfrm>
+            <a:off x="3840480" y="4690872"/>
+            <a:ext cx="5852160" cy="457200"/>
+          </a:xfrm>
+          <a:prstGeom prst="rect">
+            <a:avLst/>
+          </a:prstGeom>
+          <a:noFill/>
+        </p:spPr>
+        <p:txBody>
+          <a:bodyPr wrap="square">
+            <a:spAutoFit/>
+          </a:bodyPr>
+          <a:lstStyle/>
+          <a:p>
+            <a:pPr algn="l">
+              <a:lnSpc>
+                <a:spcPct val="115000"/>
+              </a:lnSpc>
+            </a:pPr>
+            <a:r>
+              <a:rPr sz="1300" b="0">
+                <a:solidFill>
+                  <a:srgbClr val="9A90B8"/>
+                </a:solidFill>
+                <a:latin typeface="Inter"/>
+              </a:rPr>
+              <a:t>camada de API nova: perfil, carteira, PIX, saque, histórico, KYC, bônus</a:t>
+            </a:r>
+          </a:p>
+        </p:txBody>
+      </p:sp>
+      <p:sp>
+        <p:nvSpPr>
+          <p:cNvPr id="29" name="TextBox 28"/>
+          <p:cNvSpPr txBox="1"/>
+          <p:nvPr/>
+        </p:nvSpPr>
+        <p:spPr>
+          <a:xfrm>
+            <a:off x="9875520" y="4690872"/>
+            <a:ext cx="1737360" cy="457200"/>
+          </a:xfrm>
+          <a:prstGeom prst="rect">
+            <a:avLst/>
+          </a:prstGeom>
+          <a:noFill/>
+        </p:spPr>
+        <p:txBody>
+          <a:bodyPr wrap="square">
+            <a:spAutoFit/>
+          </a:bodyPr>
+          <a:lstStyle/>
+          <a:p>
+            <a:pPr algn="r">
+              <a:lnSpc>
+                <a:spcPct val="115000"/>
+              </a:lnSpc>
+            </a:pPr>
+            <a:r>
+              <a:rPr sz="1200" b="0">
+                <a:solidFill>
+                  <a:srgbClr val="ECE7F7"/>
+                </a:solidFill>
+                <a:latin typeface="Inter"/>
+              </a:rPr>
+              <a:t>[prazo]</a:t>
+            </a:r>
+          </a:p>
+        </p:txBody>
+      </p:sp>
+      <p:sp>
+        <p:nvSpPr>
+          <p:cNvPr id="30" name="Rectangle 29"/>
+          <p:cNvSpPr/>
+          <p:nvPr/>
+        </p:nvSpPr>
+        <p:spPr>
+          <a:xfrm>
+            <a:off x="731520" y="5212080"/>
+            <a:ext cx="10881360" cy="12700"/>
+          </a:xfrm>
+          <a:prstGeom prst="rect">
+            <a:avLst/>
+          </a:prstGeom>
+          <a:solidFill>
+            <a:srgbClr val="2A1547"/>
+          </a:solidFill>
+          <a:ln>
+            <a:noFill/>
+          </a:ln>
+        </p:spPr>
+        <p:style>
+          <a:lnRef idx="1">
+            <a:schemeClr val="accent1"/>
+          </a:lnRef>
+          <a:fillRef idx="3">
+            <a:schemeClr val="accent1"/>
+          </a:fillRef>
+          <a:effectRef idx="2">
+            <a:schemeClr val="accent1"/>
+          </a:effectRef>
+          <a:fontRef idx="minor">
+            <a:schemeClr val="lt1"/>
+          </a:fontRef>
+        </p:style>
+        <p:txBody>
+          <a:bodyPr rtlCol="0" anchor="ctr"/>
+          <a:lstStyle/>
+          <a:p>
+            <a:pPr algn="ctr"/>
+          </a:p>
+        </p:txBody>
+      </p:sp>
+      <p:sp>
+        <p:nvSpPr>
+          <p:cNvPr id="31" name="TextBox 30"/>
+          <p:cNvSpPr txBox="1"/>
+          <p:nvPr/>
+        </p:nvSpPr>
+        <p:spPr>
+          <a:xfrm>
+            <a:off x="731520" y="5303520"/>
+            <a:ext cx="548640" cy="457200"/>
+          </a:xfrm>
+          <a:prstGeom prst="rect">
+            <a:avLst/>
+          </a:prstGeom>
+          <a:noFill/>
+        </p:spPr>
+        <p:txBody>
+          <a:bodyPr wrap="square">
+            <a:spAutoFit/>
+          </a:bodyPr>
+          <a:lstStyle/>
+          <a:p>
+            <a:pPr algn="l">
+              <a:lnSpc>
+                <a:spcPct val="100000"/>
+              </a:lnSpc>
+            </a:pPr>
+            <a:r>
+              <a:rPr sz="2800" b="0">
+                <a:solidFill>
+                  <a:srgbClr val="E145FF"/>
+                </a:solidFill>
+                <a:latin typeface="Bebas Neue"/>
+              </a:rPr>
+              <a:t>5</a:t>
+            </a:r>
+          </a:p>
+        </p:txBody>
+      </p:sp>
+      <p:sp>
+        <p:nvSpPr>
+          <p:cNvPr id="32" name="TextBox 31"/>
+          <p:cNvSpPr txBox="1"/>
+          <p:nvPr/>
+        </p:nvSpPr>
+        <p:spPr>
+          <a:xfrm>
+            <a:off x="1371600" y="5349240"/>
+            <a:ext cx="2377440" cy="457200"/>
+          </a:xfrm>
+          <a:prstGeom prst="rect">
+            <a:avLst/>
+          </a:prstGeom>
+          <a:noFill/>
+        </p:spPr>
+        <p:txBody>
+          <a:bodyPr wrap="square">
+            <a:spAutoFit/>
+          </a:bodyPr>
+          <a:lstStyle/>
+          <a:p>
+            <a:pPr algn="l">
+              <a:lnSpc>
+                <a:spcPct val="115000"/>
+              </a:lnSpc>
+            </a:pPr>
+            <a:r>
+              <a:rPr sz="1500" b="1">
+                <a:solidFill>
+                  <a:srgbClr val="ECE7F7"/>
+                </a:solidFill>
+                <a:latin typeface="Inter"/>
+              </a:rPr>
+              <a:t>Go-live</a:t>
+            </a:r>
+          </a:p>
+        </p:txBody>
+      </p:sp>
+      <p:sp>
+        <p:nvSpPr>
+          <p:cNvPr id="33" name="TextBox 32"/>
+          <p:cNvSpPr txBox="1"/>
+          <p:nvPr/>
+        </p:nvSpPr>
+        <p:spPr>
+          <a:xfrm>
+            <a:off x="3840480" y="5349240"/>
+            <a:ext cx="5852160" cy="457200"/>
+          </a:xfrm>
+          <a:prstGeom prst="rect">
+            <a:avLst/>
+          </a:prstGeom>
+          <a:noFill/>
+        </p:spPr>
+        <p:txBody>
+          <a:bodyPr wrap="square">
+            <a:spAutoFit/>
+          </a:bodyPr>
+          <a:lstStyle/>
+          <a:p>
+            <a:pPr algn="l">
+              <a:lnSpc>
+                <a:spcPct val="115000"/>
+              </a:lnSpc>
+            </a:pPr>
+            <a:r>
+              <a:rPr sz="1300" b="0">
+                <a:solidFill>
+                  <a:srgbClr val="9A90B8"/>
+                </a:solidFill>
+                <a:latin typeface="Inter"/>
+              </a:rPr>
+              <a:t>SEO, analytics, textos legais, monitoramento, cutover de domínio</a:t>
+            </a:r>
+          </a:p>
+        </p:txBody>
+      </p:sp>
+      <p:sp>
+        <p:nvSpPr>
+          <p:cNvPr id="34" name="TextBox 33"/>
+          <p:cNvSpPr txBox="1"/>
+          <p:nvPr/>
+        </p:nvSpPr>
+        <p:spPr>
+          <a:xfrm>
+            <a:off x="9875520" y="5349240"/>
+            <a:ext cx="1737360" cy="457200"/>
+          </a:xfrm>
+          <a:prstGeom prst="rect">
+            <a:avLst/>
+          </a:prstGeom>
+          <a:noFill/>
+        </p:spPr>
+        <p:txBody>
+          <a:bodyPr wrap="square">
+            <a:spAutoFit/>
+          </a:bodyPr>
+          <a:lstStyle/>
+          <a:p>
+            <a:pPr algn="r">
+              <a:lnSpc>
+                <a:spcPct val="115000"/>
+              </a:lnSpc>
+            </a:pPr>
+            <a:r>
+              <a:rPr sz="1200" b="0">
+                <a:solidFill>
+                  <a:srgbClr val="ECE7F7"/>
+                </a:solidFill>
+                <a:latin typeface="Inter"/>
+              </a:rPr>
+              <a:t>[prazo]</a:t>
+            </a:r>
+          </a:p>
+        </p:txBody>
+      </p:sp>
+      <p:sp>
+        <p:nvSpPr>
+          <p:cNvPr id="35" name="Rectangle 34"/>
+          <p:cNvSpPr/>
+          <p:nvPr/>
+        </p:nvSpPr>
+        <p:spPr>
+          <a:xfrm>
+            <a:off x="731520" y="5870448"/>
+            <a:ext cx="10881360" cy="12700"/>
+          </a:xfrm>
+          <a:prstGeom prst="rect">
+            <a:avLst/>
+          </a:prstGeom>
+          <a:solidFill>
+            <a:srgbClr val="2A1547"/>
+          </a:solidFill>
+          <a:ln>
+            <a:noFill/>
+          </a:ln>
+        </p:spPr>
+        <p:style>
+          <a:lnRef idx="1">
+            <a:schemeClr val="accent1"/>
+          </a:lnRef>
+          <a:fillRef idx="3">
+            <a:schemeClr val="accent1"/>
+          </a:fillRef>
+          <a:effectRef idx="2">
+            <a:schemeClr val="accent1"/>
+          </a:effectRef>
+          <a:fontRef idx="minor">
+            <a:schemeClr val="lt1"/>
+          </a:fontRef>
+        </p:style>
+        <p:txBody>
+          <a:bodyPr rtlCol="0" anchor="ctr"/>
+          <a:lstStyle/>
+          <a:p>
+            <a:pPr algn="ctr"/>
+          </a:p>
+        </p:txBody>
+      </p:sp>
+      <p:sp>
+        <p:nvSpPr>
+          <p:cNvPr id="36" name="TextBox 35"/>
+          <p:cNvSpPr txBox="1"/>
+          <p:nvPr/>
+        </p:nvSpPr>
+        <p:spPr>
+          <a:xfrm>
+            <a:off x="731520" y="5989320"/>
+            <a:ext cx="10972800" cy="365760"/>
+          </a:xfrm>
+          <a:prstGeom prst="rect">
+            <a:avLst/>
+          </a:prstGeom>
+          <a:noFill/>
+        </p:spPr>
+        <p:txBody>
+          <a:bodyPr wrap="square">
+            <a:spAutoFit/>
+          </a:bodyPr>
+          <a:lstStyle/>
+          <a:p>
+            <a:pPr algn="l">
+              <a:lnSpc>
+                <a:spcPct val="115000"/>
+              </a:lnSpc>
+            </a:pPr>
+            <a:r>
+              <a:rPr sz="1100" b="0">
+                <a:solidFill>
+                  <a:srgbClr val="9A90B8"/>
+                </a:solidFill>
+                <a:latin typeface="Inter"/>
+              </a:rPr>
+              <a:t>Fora de escopo: sportsbook novo, app nativo, programa de afiliados, idiomas além de pt-BR.</a:t>
             </a:r>
           </a:p>
         </p:txBody>
@@ -7319,7 +8303,7 @@
                 </a:solidFill>
                 <a:latin typeface="Inter"/>
               </a:rPr>
-              <a:t>RISCOS</a:t>
+              <a:t>PARA COMEÇAR</a:t>
             </a:r>
           </a:p>
         </p:txBody>
@@ -7358,7 +8342,7 @@
                 </a:solidFill>
                 <a:latin typeface="Bebas Neue"/>
               </a:rPr>
-              <a:t>O que pode dar errado, e o que fazemos</a:t>
+              <a:t>O que precisamos da GirosBet</a:t>
             </a:r>
           </a:p>
         </p:txBody>
@@ -7372,305 +8356,128 @@
         <p:spPr>
           <a:xfrm>
             <a:off x="731520" y="2011680"/>
-            <a:ext cx="3108960" cy="822960"/>
-          </a:xfrm>
-          <a:prstGeom prst="rect">
-            <a:avLst/>
-          </a:prstGeom>
-          <a:noFill/>
-        </p:spPr>
-        <p:txBody>
-          <a:bodyPr wrap="square">
-            <a:spAutoFit/>
-          </a:bodyPr>
-          <a:lstStyle/>
-          <a:p>
-            <a:pPr algn="l">
-              <a:lnSpc>
-                <a:spcPct val="115000"/>
-              </a:lnSpc>
-            </a:pPr>
-            <a:r>
-              <a:rPr sz="1500" b="1">
-                <a:solidFill>
-                  <a:srgbClr val="E145FF"/>
-                </a:solidFill>
-                <a:latin typeface="Inter"/>
-              </a:rPr>
-              <a:t>Backend desconhecido</a:t>
-            </a:r>
-          </a:p>
-        </p:txBody>
-      </p:sp>
-      <p:sp>
-        <p:nvSpPr>
-          <p:cNvPr id="7" name="TextBox 6"/>
-          <p:cNvSpPr txBox="1"/>
-          <p:nvPr/>
-        </p:nvSpPr>
-        <p:spPr>
-          <a:xfrm>
-            <a:off x="4023360" y="2011680"/>
-            <a:ext cx="7498079" cy="822960"/>
-          </a:xfrm>
-          <a:prstGeom prst="rect">
-            <a:avLst/>
-          </a:prstGeom>
-          <a:noFill/>
-        </p:spPr>
-        <p:txBody>
-          <a:bodyPr wrap="square">
-            <a:spAutoFit/>
-          </a:bodyPr>
-          <a:lstStyle/>
-          <a:p>
-            <a:pPr algn="l">
-              <a:lnSpc>
-                <a:spcPct val="130000"/>
-              </a:lnSpc>
-            </a:pPr>
-            <a:r>
-              <a:rPr sz="1400" b="0">
+            <a:ext cx="10515600" cy="4114800"/>
+          </a:xfrm>
+          <a:prstGeom prst="rect">
+            <a:avLst/>
+          </a:prstGeom>
+          <a:noFill/>
+        </p:spPr>
+        <p:txBody>
+          <a:bodyPr wrap="square">
+            <a:spAutoFit/>
+          </a:bodyPr>
+          <a:lstStyle/>
+          <a:p>
+            <a:pPr algn="l">
+              <a:lnSpc>
+                <a:spcPct val="145000"/>
+              </a:lnSpc>
+            </a:pPr>
+            <a:r>
+              <a:rPr sz="1500" b="0">
                 <a:solidFill>
                   <a:srgbClr val="ECE7F7"/>
                 </a:solidFill>
                 <a:latin typeface="Inter"/>
               </a:rPr>
-              <a:t>A área logada é o maior custo. Spike de 1 semana lendo a documentação antes de fechar a fase 4.</a:t>
-            </a:r>
-          </a:p>
-        </p:txBody>
-      </p:sp>
-      <p:sp>
-        <p:nvSpPr>
-          <p:cNvPr id="8" name="TextBox 7"/>
-          <p:cNvSpPr txBox="1"/>
-          <p:nvPr/>
-        </p:nvSpPr>
-        <p:spPr>
-          <a:xfrm>
-            <a:off x="731520" y="2926080"/>
-            <a:ext cx="3108960" cy="822960"/>
-          </a:xfrm>
-          <a:prstGeom prst="rect">
-            <a:avLst/>
-          </a:prstGeom>
-          <a:noFill/>
-        </p:spPr>
-        <p:txBody>
-          <a:bodyPr wrap="square">
-            <a:spAutoFit/>
-          </a:bodyPr>
-          <a:lstStyle/>
-          <a:p>
-            <a:pPr algn="l">
-              <a:lnSpc>
-                <a:spcPct val="115000"/>
-              </a:lnSpc>
-            </a:pPr>
-            <a:r>
-              <a:rPr sz="1500" b="1">
-                <a:solidFill>
-                  <a:srgbClr val="E145FF"/>
-                </a:solidFill>
-                <a:latin typeface="Inter"/>
-              </a:rPr>
-              <a:t>Paridade de conteúdo</a:t>
-            </a:r>
-          </a:p>
-        </p:txBody>
-      </p:sp>
-      <p:sp>
-        <p:nvSpPr>
-          <p:cNvPr id="9" name="TextBox 8"/>
-          <p:cNvSpPr txBox="1"/>
-          <p:nvPr/>
-        </p:nvSpPr>
-        <p:spPr>
-          <a:xfrm>
-            <a:off x="4023360" y="2926080"/>
-            <a:ext cx="7498079" cy="822960"/>
-          </a:xfrm>
-          <a:prstGeom prst="rect">
-            <a:avLst/>
-          </a:prstGeom>
-          <a:noFill/>
-        </p:spPr>
-        <p:txBody>
-          <a:bodyPr wrap="square">
-            <a:spAutoFit/>
-          </a:bodyPr>
-          <a:lstStyle/>
-          <a:p>
-            <a:pPr algn="l">
-              <a:lnSpc>
-                <a:spcPct val="130000"/>
-              </a:lnSpc>
-            </a:pPr>
-            <a:r>
-              <a:rPr sz="1400" b="0">
+              <a:t>1.  Kit de marca: logo em vetor, paleta oficial (o roxo principal é #901bf7 ou #e145ff?), fontes, mascote.</a:t>
+            </a:r>
+          </a:p>
+          <a:p>
+            <a:pPr algn="l">
+              <a:lnSpc>
+                <a:spcPct val="145000"/>
+              </a:lnSpc>
+            </a:pPr>
+            <a:r>
+              <a:rPr sz="1500" b="0">
                 <a:solidFill>
                   <a:srgbClr val="ECE7F7"/>
                 </a:solidFill>
                 <a:latin typeface="Inter"/>
               </a:rPr>
-              <a:t>Catálogo importado por job, não cadastrado à mão. O CMS já sincroniza com o agregador.</a:t>
-            </a:r>
-          </a:p>
-        </p:txBody>
-      </p:sp>
-      <p:sp>
-        <p:nvSpPr>
-          <p:cNvPr id="10" name="TextBox 9"/>
-          <p:cNvSpPr txBox="1"/>
-          <p:nvPr/>
-        </p:nvSpPr>
-        <p:spPr>
-          <a:xfrm>
-            <a:off x="731520" y="3840480"/>
-            <a:ext cx="3108960" cy="822960"/>
-          </a:xfrm>
-          <a:prstGeom prst="rect">
-            <a:avLst/>
-          </a:prstGeom>
-          <a:noFill/>
-        </p:spPr>
-        <p:txBody>
-          <a:bodyPr wrap="square">
-            <a:spAutoFit/>
-          </a:bodyPr>
-          <a:lstStyle/>
-          <a:p>
-            <a:pPr algn="l">
-              <a:lnSpc>
-                <a:spcPct val="115000"/>
-              </a:lnSpc>
-            </a:pPr>
-            <a:r>
-              <a:rPr sz="1500" b="1">
-                <a:solidFill>
-                  <a:srgbClr val="E145FF"/>
-                </a:solidFill>
-                <a:latin typeface="Inter"/>
-              </a:rPr>
-              <a:t>Regressão no BetAki</a:t>
-            </a:r>
-          </a:p>
-        </p:txBody>
-      </p:sp>
-      <p:sp>
-        <p:nvSpPr>
-          <p:cNvPr id="11" name="TextBox 10"/>
-          <p:cNvSpPr txBox="1"/>
-          <p:nvPr/>
-        </p:nvSpPr>
-        <p:spPr>
-          <a:xfrm>
-            <a:off x="4023360" y="3840480"/>
-            <a:ext cx="7498079" cy="822960"/>
-          </a:xfrm>
-          <a:prstGeom prst="rect">
-            <a:avLst/>
-          </a:prstGeom>
-          <a:noFill/>
-        </p:spPr>
-        <p:txBody>
-          <a:bodyPr wrap="square">
-            <a:spAutoFit/>
-          </a:bodyPr>
-          <a:lstStyle/>
-          <a:p>
-            <a:pPr algn="l">
-              <a:lnSpc>
-                <a:spcPct val="130000"/>
-              </a:lnSpc>
-            </a:pPr>
-            <a:r>
-              <a:rPr sz="1400" b="0">
+              <a:t>2.  Documentação e sandbox do backend e do agregador: auth, carteira, PIX, catálogo, lançamento, webhooks.</a:t>
+            </a:r>
+          </a:p>
+          <a:p>
+            <a:pPr algn="l">
+              <a:lnSpc>
+                <a:spcPct val="145000"/>
+              </a:lnSpc>
+            </a:pPr>
+            <a:r>
+              <a:rPr sz="1500" b="0">
                 <a:solidFill>
                   <a:srgbClr val="ECE7F7"/>
                 </a:solidFill>
                 <a:latin typeface="Inter"/>
               </a:rPr>
-              <a:t>White-label feito com o BetAki como marca 1 e comparação visual antes de qualquer merge.</a:t>
-            </a:r>
-          </a:p>
-        </p:txBody>
-      </p:sp>
-      <p:sp>
-        <p:nvSpPr>
-          <p:cNvPr id="12" name="TextBox 11"/>
-          <p:cNvSpPr txBox="1"/>
-          <p:nvPr/>
-        </p:nvSpPr>
-        <p:spPr>
-          <a:xfrm>
-            <a:off x="731520" y="4754880"/>
-            <a:ext cx="3108960" cy="822960"/>
-          </a:xfrm>
-          <a:prstGeom prst="rect">
-            <a:avLst/>
-          </a:prstGeom>
-          <a:noFill/>
-        </p:spPr>
-        <p:txBody>
-          <a:bodyPr wrap="square">
-            <a:spAutoFit/>
-          </a:bodyPr>
-          <a:lstStyle/>
-          <a:p>
-            <a:pPr algn="l">
-              <a:lnSpc>
-                <a:spcPct val="115000"/>
-              </a:lnSpc>
-            </a:pPr>
-            <a:r>
-              <a:rPr sz="1500" b="1">
-                <a:solidFill>
-                  <a:srgbClr val="E145FF"/>
-                </a:solidFill>
-                <a:latin typeface="Inter"/>
-              </a:rPr>
-              <a:t>Escopo crescendo</a:t>
-            </a:r>
-          </a:p>
-        </p:txBody>
-      </p:sp>
-      <p:sp>
-        <p:nvSpPr>
-          <p:cNvPr id="13" name="TextBox 12"/>
-          <p:cNvSpPr txBox="1"/>
-          <p:nvPr/>
-        </p:nvSpPr>
-        <p:spPr>
-          <a:xfrm>
-            <a:off x="4023360" y="4754880"/>
-            <a:ext cx="7498079" cy="822960"/>
-          </a:xfrm>
-          <a:prstGeom prst="rect">
-            <a:avLst/>
-          </a:prstGeom>
-          <a:noFill/>
-        </p:spPr>
-        <p:txBody>
-          <a:bodyPr wrap="square">
-            <a:spAutoFit/>
-          </a:bodyPr>
-          <a:lstStyle/>
-          <a:p>
-            <a:pPr algn="l">
-              <a:lnSpc>
-                <a:spcPct val="130000"/>
-              </a:lnSpc>
-            </a:pPr>
-            <a:r>
-              <a:rPr sz="1400" b="0">
+              <a:t>3.  Vendor de sportsbook e de KYC, com credenciais de teste.</a:t>
+            </a:r>
+          </a:p>
+          <a:p>
+            <a:pPr algn="l">
+              <a:lnSpc>
+                <a:spcPct val="145000"/>
+              </a:lnSpc>
+            </a:pPr>
+            <a:r>
+              <a:rPr sz="1500" b="0">
                 <a:solidFill>
                   <a:srgbClr val="ECE7F7"/>
                 </a:solidFill>
                 <a:latin typeface="Inter"/>
               </a:rPr>
-              <a:t>Tudo fora da tabela de fases entra como fase 6, negociada à parte.</a:t>
+              <a:t>4.  Textos legais, licenciamento e selos do rodapé.</a:t>
+            </a:r>
+          </a:p>
+          <a:p>
+            <a:pPr algn="l">
+              <a:lnSpc>
+                <a:spcPct val="145000"/>
+              </a:lnSpc>
+            </a:pPr>
+            <a:r>
+              <a:rPr sz="1500" b="0">
+                <a:solidFill>
+                  <a:srgbClr val="ECE7F7"/>
+                </a:solidFill>
+                <a:latin typeface="Inter"/>
+              </a:rPr>
+              <a:t>5.  Contas de GTM/GA, pixel de afiliados, chat.</a:t>
+            </a:r>
+          </a:p>
+          <a:p>
+            <a:pPr algn="l">
+              <a:lnSpc>
+                <a:spcPct val="145000"/>
+              </a:lnSpc>
+            </a:pPr>
+            <a:r>
+              <a:rPr sz="1500" b="0">
+                <a:solidFill>
+                  <a:srgbClr val="ECE7F7"/>
+                </a:solidFill>
+                <a:latin typeface="Inter"/>
+              </a:rPr>
+              <a:t>6.  Domínio e infra de deploy, ou definimos a nossa.</a:t>
+            </a:r>
+          </a:p>
+          <a:p>
+            <a:pPr algn="l">
+              <a:lnSpc>
+                <a:spcPct val="145000"/>
+              </a:lnSpc>
+            </a:pPr>
+            <a:r>
+              <a:rPr sz="1500" b="0">
+                <a:solidFill>
+                  <a:srgbClr val="ECE7F7"/>
+                </a:solidFill>
+                <a:latin typeface="Inter"/>
+              </a:rPr>
+              <a:t>7.  Uma pessoa de produto do lado da GirosBet para validar a área logada.</a:t>
             </a:r>
           </a:p>
         </p:txBody>

</xml_diff>